<commit_message>
Update presentation with embedded graphs
- Replaced text/equations with actual visualization graphs
- 10 graphs embedded across 14 slides:
  • Task 1: TPR/FPR comparison, detection breakdown, metrics, confidence
  • Task 2: Real accepted, decoys rejected, missed & rescued
  • Task 3: 3D method, height consistency, summary dashboard
- Still 14 slides total (3-4 per task)
- Professional visual impact with data-driven results
- File size: 2.7MB with high-quality embedded images

Co-Authored-By: Claude Sonnet 4.5 <noreply@anthropic.com>
</commit_message>
<xml_diff>
--- a/Fire_Extinguisher_Detection_Presentation.pptx
+++ b/Fire_Extinguisher_Detection_Presentation.pptx
@@ -2275,14 +2275,14 @@
               <a:buNone/>
             </a:pPr>
             <a:r>
-              <a:rPr lang="en-US" sz="3600" b="1" dirty="0">
+              <a:rPr lang="en-US" sz="3200" b="1" dirty="0">
                 <a:solidFill>
                   <a:srgbClr val="1E2761"/>
                 </a:solidFill>
               </a:rPr>
-              <a:t>Stage 3: 3D Localization and Tracking</a:t>
-            </a:r>
-            <a:endParaRPr lang="en-US" sz="3600" dirty="0"/>
+              <a:t>Stage 2: Edge Cases - Missed Real Objects</a:t>
+            </a:r>
+            <a:endParaRPr lang="en-US" sz="3200" dirty="0"/>
           </a:p>
         </p:txBody>
       </p:sp>
@@ -2294,8 +2294,8 @@
         </p:nvSpPr>
         <p:spPr>
           <a:xfrm>
-            <a:off x="457200" y="868680"/>
-            <a:ext cx="8229600" cy="274320"/>
+            <a:off x="731520" y="1005840"/>
+            <a:ext cx="3657600" cy="274320"/>
           </a:xfrm>
           <a:prstGeom prst="rect">
             <a:avLst/>
@@ -2307,31 +2307,55 @@
           <a:bodyPr wrap="square" rtlCol="0" anchor="ctr"/>
           <a:lstStyle/>
           <a:p>
-            <a:pPr indent="0" marL="0">
-              <a:buNone/>
-            </a:pPr>
-            <a:r>
-              <a:rPr lang="en-US" sz="1400" i="1" dirty="0">
-                <a:solidFill>
-                  <a:srgbClr val="028090"/>
-                </a:solidFill>
-              </a:rPr>
-              <a:t>Responsible: Thanigaiarasu Shanmugam</a:t>
+            <a:pPr algn="ctr" indent="0" marL="0">
+              <a:buNone/>
+            </a:pPr>
+            <a:r>
+              <a:rPr lang="en-US" sz="1400" b="1" dirty="0">
+                <a:solidFill>
+                  <a:srgbClr val="F96167"/>
+                </a:solidFill>
+              </a:rPr>
+              <a:t>Real Missed (2 objects)</a:t>
             </a:r>
             <a:endParaRPr lang="en-US" sz="1400" dirty="0"/>
           </a:p>
         </p:txBody>
       </p:sp>
-      <p:sp>
-        <p:nvSpPr>
-          <p:cNvPr id="4" name="Text 2"/>
+      <p:pic>
+        <p:nvPicPr>
+          <p:cNvPr id="4" name="Image 0" descr="/Users/kelechiezekwe/Workspace/Computer_vision_lab/Project_work/outputs/figures/ev_real_missed.png">    </p:cNvPr>
+          <p:cNvPicPr>
+            <a:picLocks noChangeAspect="1"/>
+          </p:cNvPicPr>
+          <p:nvPr/>
+        </p:nvPicPr>
+        <p:blipFill>
+          <a:blip r:embed="rId1"/>
+          <a:stretch>
+            <a:fillRect/>
+          </a:stretch>
+        </p:blipFill>
+        <p:spPr>
+          <a:xfrm>
+            <a:off x="731520" y="1371600"/>
+            <a:ext cx="3657600" cy="2560320"/>
+          </a:xfrm>
+          <a:prstGeom prst="rect">
+            <a:avLst/>
+          </a:prstGeom>
+        </p:spPr>
+      </p:pic>
+      <p:sp>
+        <p:nvSpPr>
+          <p:cNvPr id="5" name="Text 2"/>
           <p:cNvSpPr txBox="1"/>
           <p:nvPr/>
         </p:nvSpPr>
         <p:spPr>
           <a:xfrm>
-            <a:off x="731520" y="1371600"/>
-            <a:ext cx="7680960" cy="274320"/>
+            <a:off x="4754880" y="1005840"/>
+            <a:ext cx="3657600" cy="274320"/>
           </a:xfrm>
           <a:prstGeom prst="rect">
             <a:avLst/>
@@ -2343,31 +2367,55 @@
           <a:bodyPr wrap="square" rtlCol="0" anchor="ctr"/>
           <a:lstStyle/>
           <a:p>
-            <a:pPr indent="0" marL="0">
-              <a:buNone/>
-            </a:pPr>
-            <a:r>
-              <a:rPr lang="en-US" sz="1800" b="1" dirty="0">
-                <a:solidFill>
-                  <a:srgbClr val="1E2761"/>
-                </a:solidFill>
-              </a:rPr>
-              <a:t>3D Coordinate Calculation:</a:t>
-            </a:r>
-            <a:endParaRPr lang="en-US" sz="1800" dirty="0"/>
-          </a:p>
-        </p:txBody>
-      </p:sp>
-      <p:sp>
-        <p:nvSpPr>
-          <p:cNvPr id="5" name="Text 3"/>
+            <a:pPr algn="ctr" indent="0" marL="0">
+              <a:buNone/>
+            </a:pPr>
+            <a:r>
+              <a:rPr lang="en-US" sz="1400" b="1" dirty="0">
+                <a:solidFill>
+                  <a:srgbClr val="2C5F2D"/>
+                </a:solidFill>
+              </a:rPr>
+              <a:t>Rescued by Tracking</a:t>
+            </a:r>
+            <a:endParaRPr lang="en-US" sz="1400" dirty="0"/>
+          </a:p>
+        </p:txBody>
+      </p:sp>
+      <p:pic>
+        <p:nvPicPr>
+          <p:cNvPr id="6" name="Image 1" descr="/Users/kelechiezekwe/Workspace/Computer_vision_lab/Project_work/outputs/figures/ev_real_rescued.png">    </p:cNvPr>
+          <p:cNvPicPr>
+            <a:picLocks noChangeAspect="1"/>
+          </p:cNvPicPr>
+          <p:nvPr/>
+        </p:nvPicPr>
+        <p:blipFill>
+          <a:blip r:embed="rId2"/>
+          <a:stretch>
+            <a:fillRect/>
+          </a:stretch>
+        </p:blipFill>
+        <p:spPr>
+          <a:xfrm>
+            <a:off x="4754880" y="1371600"/>
+            <a:ext cx="3657600" cy="2560320"/>
+          </a:xfrm>
+          <a:prstGeom prst="rect">
+            <a:avLst/>
+          </a:prstGeom>
+        </p:spPr>
+      </p:pic>
+      <p:sp>
+        <p:nvSpPr>
+          <p:cNvPr id="7" name="Text 3"/>
           <p:cNvSpPr txBox="1"/>
           <p:nvPr/>
         </p:nvSpPr>
         <p:spPr>
           <a:xfrm>
-            <a:off x="731520" y="1737360"/>
-            <a:ext cx="7680960" cy="822960"/>
+            <a:off x="731520" y="4206240"/>
+            <a:ext cx="7680960" cy="548640"/>
           </a:xfrm>
           <a:prstGeom prst="rect">
             <a:avLst/>
@@ -2379,152 +2427,32 @@
           <a:bodyPr wrap="square" rtlCol="0" anchor="ctr"/>
           <a:lstStyle/>
           <a:p>
-            <a:pPr marL="342900" indent="-342900">
-              <a:buSzPct val="100000"/>
-              <a:buChar char="•"/>
-            </a:pPr>
-            <a:r>
-              <a:rPr lang="en-US" sz="1500" dirty="0">
+            <a:pPr algn="ctr" indent="0" marL="0">
+              <a:buNone/>
+            </a:pPr>
+            <a:r>
+              <a:rPr lang="en-US" sz="1300" i="1" dirty="0">
                 <a:solidFill>
                   <a:srgbClr val="2C2C2C"/>
                 </a:solidFill>
               </a:rPr>
-              <a:t>• Histogram-based depth segmentation</a:t>
-            </a:r>
-            <a:endParaRPr lang="en-US" sz="1500" dirty="0"/>
-          </a:p>
-          <a:p>
-            <a:pPr marL="342900" indent="-342900">
-              <a:buSzPct val="100000"/>
-              <a:buChar char="•"/>
-            </a:pPr>
-            <a:r>
-              <a:rPr lang="en-US" sz="1500" dirty="0">
+              <a:t>Root cause: Colour/depth timing mismatch during camera motion</a:t>
+            </a:r>
+            <a:endParaRPr lang="en-US" sz="1300" dirty="0"/>
+          </a:p>
+          <a:p>
+            <a:pPr algn="ctr" indent="0" marL="0">
+              <a:buNone/>
+            </a:pPr>
+            <a:r>
+              <a:rPr lang="en-US" sz="1300" i="1" dirty="0">
                 <a:solidFill>
                   <a:srgbClr val="2C2C2C"/>
                 </a:solidFill>
               </a:rPr>
-              <a:t>• Cylinder center = front surface + 0.067m</a:t>
-            </a:r>
-            <a:endParaRPr lang="en-US" sz="1500" dirty="0"/>
-          </a:p>
-          <a:p>
-            <a:pPr marL="342900" indent="-342900">
-              <a:buSzPct val="100000"/>
-              <a:buChar char="•"/>
-            </a:pPr>
-            <a:r>
-              <a:rPr lang="en-US" sz="1500" dirty="0">
-                <a:solidFill>
-                  <a:srgbClr val="2C2C2C"/>
-                </a:solidFill>
-              </a:rPr>
-              <a:t>• Back-projection: X = (u-cx)×Z/fx, Y = (v-cy)×Z/fy</a:t>
-            </a:r>
-            <a:endParaRPr lang="en-US" sz="1500" dirty="0"/>
-          </a:p>
-        </p:txBody>
-      </p:sp>
-      <p:sp>
-        <p:nvSpPr>
-          <p:cNvPr id="6" name="Text 4"/>
-          <p:cNvSpPr txBox="1"/>
-          <p:nvPr/>
-        </p:nvSpPr>
-        <p:spPr>
-          <a:xfrm>
-            <a:off x="731520" y="2834640"/>
-            <a:ext cx="7680960" cy="274320"/>
-          </a:xfrm>
-          <a:prstGeom prst="rect">
-            <a:avLst/>
-          </a:prstGeom>
-          <a:noFill/>
-          <a:ln/>
-        </p:spPr>
-        <p:txBody>
-          <a:bodyPr wrap="square" rtlCol="0" anchor="ctr"/>
-          <a:lstStyle/>
-          <a:p>
-            <a:pPr indent="0" marL="0">
-              <a:buNone/>
-            </a:pPr>
-            <a:r>
-              <a:rPr lang="en-US" sz="1800" b="1" dirty="0">
-                <a:solidFill>
-                  <a:srgbClr val="1E2761"/>
-                </a:solidFill>
-              </a:rPr>
-              <a:t>Tracking Extension:</a:t>
-            </a:r>
-            <a:endParaRPr lang="en-US" sz="1800" dirty="0"/>
-          </a:p>
-        </p:txBody>
-      </p:sp>
-      <p:sp>
-        <p:nvSpPr>
-          <p:cNvPr id="7" name="Text 5"/>
-          <p:cNvSpPr txBox="1"/>
-          <p:nvPr/>
-        </p:nvSpPr>
-        <p:spPr>
-          <a:xfrm>
-            <a:off x="731520" y="3200400"/>
-            <a:ext cx="7680960" cy="822960"/>
-          </a:xfrm>
-          <a:prstGeom prst="rect">
-            <a:avLst/>
-          </a:prstGeom>
-          <a:noFill/>
-          <a:ln/>
-        </p:spPr>
-        <p:txBody>
-          <a:bodyPr wrap="square" rtlCol="0" anchor="ctr"/>
-          <a:lstStyle/>
-          <a:p>
-            <a:pPr marL="342900" indent="-342900">
-              <a:buSzPct val="100000"/>
-              <a:buChar char="•"/>
-            </a:pPr>
-            <a:r>
-              <a:rPr lang="en-US" sz="1500" dirty="0">
-                <a:solidFill>
-                  <a:srgbClr val="2C2C2C"/>
-                </a:solidFill>
-              </a:rPr>
-              <a:t>• Conservative rescue criteria</a:t>
-            </a:r>
-            <a:endParaRPr lang="en-US" sz="1500" dirty="0"/>
-          </a:p>
-          <a:p>
-            <a:pPr marL="342900" indent="-342900">
-              <a:buSzPct val="100000"/>
-              <a:buChar char="•"/>
-            </a:pPr>
-            <a:r>
-              <a:rPr lang="en-US" sz="1500" dirty="0">
-                <a:solidFill>
-                  <a:srgbClr val="2C2C2C"/>
-                </a:solidFill>
-              </a:rPr>
-              <a:t>• Recovers temporal edge cases</a:t>
-            </a:r>
-            <a:endParaRPr lang="en-US" sz="1500" dirty="0"/>
-          </a:p>
-          <a:p>
-            <a:pPr marL="342900" indent="-342900">
-              <a:buSzPct val="100000"/>
-              <a:buChar char="•"/>
-            </a:pPr>
-            <a:r>
-              <a:rPr lang="en-US" sz="1500" dirty="0">
-                <a:solidFill>
-                  <a:srgbClr val="2C2C2C"/>
-                </a:solidFill>
-              </a:rPr>
-              <a:t>• Maintains 0% FPR</a:t>
-            </a:r>
-            <a:endParaRPr lang="en-US" sz="1500" dirty="0"/>
+              <a:t>Solution: Stage 3 tracking recovers both!</a:t>
+            </a:r>
+            <a:endParaRPr lang="en-US" sz="1300" dirty="0"/>
           </a:p>
         </p:txBody>
       </p:sp>
@@ -2590,7 +2518,7 @@
                   <a:srgbClr val="1E2761"/>
                 </a:solidFill>
               </a:rPr>
-              <a:t>Stage 3: Perfect Final Performance</a:t>
+              <a:t>Stage 3: 3D Localization Method</a:t>
             </a:r>
             <a:endParaRPr lang="en-US" sz="3600" dirty="0"/>
           </a:p>
@@ -2604,8 +2532,8 @@
         </p:nvSpPr>
         <p:spPr>
           <a:xfrm>
-            <a:off x="731520" y="1097280"/>
-            <a:ext cx="3657600" cy="274320"/>
+            <a:off x="457200" y="868680"/>
+            <a:ext cx="8229600" cy="274320"/>
           </a:xfrm>
           <a:prstGeom prst="rect">
             <a:avLst/>
@@ -2621,27 +2549,107 @@
               <a:buNone/>
             </a:pPr>
             <a:r>
-              <a:rPr lang="en-US" sz="1800" b="1" dirty="0">
+              <a:rPr lang="en-US" sz="1400" i="1" dirty="0">
                 <a:solidFill>
                   <a:srgbClr val="028090"/>
                 </a:solidFill>
               </a:rPr>
-              <a:t>3D Accuracy:</a:t>
-            </a:r>
-            <a:endParaRPr lang="en-US" sz="1800" dirty="0"/>
-          </a:p>
-        </p:txBody>
-      </p:sp>
-      <p:sp>
-        <p:nvSpPr>
-          <p:cNvPr id="4" name="Text 2"/>
+              <a:t>Responsible: Thanigaiarasu Shanmugam</a:t>
+            </a:r>
+            <a:endParaRPr lang="en-US" sz="1400" dirty="0"/>
+          </a:p>
+        </p:txBody>
+      </p:sp>
+      <p:pic>
+        <p:nvPicPr>
+          <p:cNvPr id="4" name="Image 0" descr="/Users/kelechiezekwe/Workspace/Computer_vision_lab/Project_work/outputs/figures/fig_3d_method.png">    </p:cNvPr>
+          <p:cNvPicPr>
+            <a:picLocks noChangeAspect="1"/>
+          </p:cNvPicPr>
+          <p:nvPr/>
+        </p:nvPicPr>
+        <p:blipFill>
+          <a:blip r:embed="rId1"/>
+          <a:stretch>
+            <a:fillRect/>
+          </a:stretch>
+        </p:blipFill>
+        <p:spPr>
+          <a:xfrm>
+            <a:off x="731520" y="1371600"/>
+            <a:ext cx="3657600" cy="3200400"/>
+          </a:xfrm>
+          <a:prstGeom prst="rect">
+            <a:avLst/>
+          </a:prstGeom>
+        </p:spPr>
+      </p:pic>
+      <p:sp>
+        <p:nvSpPr>
+          <p:cNvPr id="5" name="Shape 2"/>
+          <p:cNvSpPr/>
+          <p:nvPr/>
+        </p:nvSpPr>
+        <p:spPr>
+          <a:xfrm>
+            <a:off x="4754880" y="1371600"/>
+            <a:ext cx="3657600" cy="2011680"/>
+          </a:xfrm>
+          <a:prstGeom prst="rect">
+            <a:avLst/>
+          </a:prstGeom>
+          <a:solidFill>
+            <a:srgbClr val="F5F5F5"/>
+          </a:solidFill>
+          <a:ln/>
+        </p:spPr>
+      </p:sp>
+      <p:sp>
+        <p:nvSpPr>
+          <p:cNvPr id="6" name="Text 3"/>
           <p:cNvSpPr txBox="1"/>
           <p:nvPr/>
         </p:nvSpPr>
         <p:spPr>
           <a:xfrm>
-            <a:off x="731520" y="1463040"/>
-            <a:ext cx="3657600" cy="822960"/>
+            <a:off x="4937760" y="1463040"/>
+            <a:ext cx="3291840" cy="274320"/>
+          </a:xfrm>
+          <a:prstGeom prst="rect">
+            <a:avLst/>
+          </a:prstGeom>
+          <a:noFill/>
+          <a:ln/>
+        </p:spPr>
+        <p:txBody>
+          <a:bodyPr wrap="square" rtlCol="0" anchor="ctr"/>
+          <a:lstStyle/>
+          <a:p>
+            <a:pPr indent="0" marL="0">
+              <a:buNone/>
+            </a:pPr>
+            <a:r>
+              <a:rPr lang="en-US" sz="1400" b="1" dirty="0">
+                <a:solidFill>
+                  <a:srgbClr val="1E2761"/>
+                </a:solidFill>
+              </a:rPr>
+              <a:t>3D Coordinate Calculation:</a:t>
+            </a:r>
+            <a:endParaRPr lang="en-US" sz="1400" dirty="0"/>
+          </a:p>
+        </p:txBody>
+      </p:sp>
+      <p:sp>
+        <p:nvSpPr>
+          <p:cNvPr id="7" name="Text 4"/>
+          <p:cNvSpPr txBox="1"/>
+          <p:nvPr/>
+        </p:nvSpPr>
+        <p:spPr>
+          <a:xfrm>
+            <a:off x="4937760" y="1828800"/>
+            <a:ext cx="3291840" cy="1097280"/>
           </a:xfrm>
           <a:prstGeom prst="rect">
             <a:avLst/>
@@ -2658,14 +2666,14 @@
               <a:buChar char="•"/>
             </a:pPr>
             <a:r>
-              <a:rPr lang="en-US" sz="1400" dirty="0">
+              <a:rPr lang="en-US" sz="1200" dirty="0">
                 <a:solidFill>
                   <a:srgbClr val="2C2C2C"/>
                 </a:solidFill>
               </a:rPr>
-              <a:t>• Height above floor: 0.49 ± 0.05m</a:t>
-            </a:r>
-            <a:endParaRPr lang="en-US" sz="1400" dirty="0"/>
+              <a:t>• Histogram-based depth segmentation</a:t>
+            </a:r>
+            <a:endParaRPr lang="en-US" sz="1200" dirty="0"/>
           </a:p>
           <a:p>
             <a:pPr marL="342900" indent="-342900">
@@ -2673,14 +2681,14 @@
               <a:buChar char="•"/>
             </a:pPr>
             <a:r>
-              <a:rPr lang="en-US" sz="1400" dirty="0">
+              <a:rPr lang="en-US" sz="1200" dirty="0">
                 <a:solidFill>
                   <a:srgbClr val="2C2C2C"/>
                 </a:solidFill>
               </a:rPr>
-              <a:t>• Consistent across all frames</a:t>
-            </a:r>
-            <a:endParaRPr lang="en-US" sz="1400" dirty="0"/>
+              <a:t>• Cylinder center = front + 0.067m</a:t>
+            </a:r>
+            <a:endParaRPr lang="en-US" sz="1200" dirty="0"/>
           </a:p>
           <a:p>
             <a:pPr marL="342900" indent="-342900">
@@ -2688,165 +2696,78 @@
               <a:buChar char="•"/>
             </a:pPr>
             <a:r>
-              <a:rPr lang="en-US" sz="1400" dirty="0">
+              <a:rPr lang="en-US" sz="1200" dirty="0">
                 <a:solidFill>
                   <a:srgbClr val="2C2C2C"/>
                 </a:solidFill>
               </a:rPr>
-              <a:t>• Validates 3D estimation accuracy</a:t>
-            </a:r>
-            <a:endParaRPr lang="en-US" sz="1400" dirty="0"/>
-          </a:p>
-        </p:txBody>
-      </p:sp>
-      <p:sp>
-        <p:nvSpPr>
-          <p:cNvPr id="5" name="Text 3"/>
-          <p:cNvSpPr txBox="1"/>
-          <p:nvPr/>
-        </p:nvSpPr>
-        <p:spPr>
-          <a:xfrm>
-            <a:off x="4754880" y="1097280"/>
-            <a:ext cx="3657600" cy="274320"/>
-          </a:xfrm>
-          <a:prstGeom prst="rect">
-            <a:avLst/>
-          </a:prstGeom>
-          <a:noFill/>
-          <a:ln/>
-        </p:spPr>
-        <p:txBody>
-          <a:bodyPr wrap="square" rtlCol="0" anchor="ctr"/>
-          <a:lstStyle/>
-          <a:p>
-            <a:pPr indent="0" marL="0">
-              <a:buNone/>
-            </a:pPr>
-            <a:r>
-              <a:rPr lang="en-US" sz="1800" b="1" dirty="0">
-                <a:solidFill>
-                  <a:srgbClr val="028090"/>
-                </a:solidFill>
-              </a:rPr>
-              <a:t>Tracking Results:</a:t>
-            </a:r>
-            <a:endParaRPr lang="en-US" sz="1800" dirty="0"/>
-          </a:p>
-        </p:txBody>
-      </p:sp>
-      <p:sp>
-        <p:nvSpPr>
-          <p:cNvPr id="6" name="Text 4"/>
-          <p:cNvSpPr txBox="1"/>
-          <p:nvPr/>
-        </p:nvSpPr>
-        <p:spPr>
-          <a:xfrm>
-            <a:off x="4754880" y="1463040"/>
-            <a:ext cx="3657600" cy="1097280"/>
-          </a:xfrm>
-          <a:prstGeom prst="rect">
-            <a:avLst/>
-          </a:prstGeom>
-          <a:noFill/>
-          <a:ln/>
-        </p:spPr>
-        <p:txBody>
-          <a:bodyPr wrap="square" rtlCol="0" anchor="ctr"/>
-          <a:lstStyle/>
+              <a:t>• X = (u-cx)×Z/fx</a:t>
+            </a:r>
+            <a:endParaRPr lang="en-US" sz="1200" dirty="0"/>
+          </a:p>
           <a:p>
             <a:pPr marL="342900" indent="-342900">
               <a:buSzPct val="100000"/>
               <a:buChar char="•"/>
             </a:pPr>
             <a:r>
+              <a:rPr lang="en-US" sz="1200" dirty="0">
+                <a:solidFill>
+                  <a:srgbClr val="2C2C2C"/>
+                </a:solidFill>
+              </a:rPr>
+              <a:t>• Y = (v-cy)×Z/fy</a:t>
+            </a:r>
+            <a:endParaRPr lang="en-US" sz="1200" dirty="0"/>
+          </a:p>
+        </p:txBody>
+      </p:sp>
+      <p:sp>
+        <p:nvSpPr>
+          <p:cNvPr id="8" name="Text 5"/>
+          <p:cNvSpPr txBox="1"/>
+          <p:nvPr/>
+        </p:nvSpPr>
+        <p:spPr>
+          <a:xfrm>
+            <a:off x="4937760" y="3108960"/>
+            <a:ext cx="3291840" cy="228600"/>
+          </a:xfrm>
+          <a:prstGeom prst="rect">
+            <a:avLst/>
+          </a:prstGeom>
+          <a:noFill/>
+          <a:ln/>
+        </p:spPr>
+        <p:txBody>
+          <a:bodyPr wrap="square" rtlCol="0" anchor="ctr"/>
+          <a:lstStyle/>
+          <a:p>
+            <a:pPr indent="0" marL="0">
+              <a:buNone/>
+            </a:pPr>
+            <a:r>
               <a:rPr lang="en-US" sz="1400" b="1" dirty="0">
                 <a:solidFill>
-                  <a:srgbClr val="2C5F2D"/>
-                </a:solidFill>
-              </a:rPr>
-              <a:t>• 2 real objects rescued (timing issues)</a:t>
+                  <a:srgbClr val="1E2761"/>
+                </a:solidFill>
+              </a:rPr>
+              <a:t>Tracking Extension:</a:t>
             </a:r>
             <a:endParaRPr lang="en-US" sz="1400" dirty="0"/>
           </a:p>
-          <a:p>
-            <a:pPr marL="342900" indent="-342900">
-              <a:buSzPct val="100000"/>
-              <a:buChar char="•"/>
-            </a:pPr>
-            <a:r>
-              <a:rPr lang="en-US" sz="1400" b="1" dirty="0">
-                <a:solidFill>
-                  <a:srgbClr val="2C5F2D"/>
-                </a:solidFill>
-              </a:rPr>
-              <a:t>• 0 decoys added (conservative)</a:t>
-            </a:r>
-            <a:endParaRPr lang="en-US" sz="1400" dirty="0"/>
-          </a:p>
-          <a:p>
-            <a:pPr marL="342900" indent="-342900">
-              <a:buSzPct val="100000"/>
-              <a:buChar char="•"/>
-            </a:pPr>
-            <a:r>
-              <a:rPr lang="en-US" sz="1400" b="1" dirty="0">
-                <a:solidFill>
-                  <a:srgbClr val="2C5F2D"/>
-                </a:solidFill>
-              </a:rPr>
-              <a:t>• Final TPR: 100% (45/45)</a:t>
-            </a:r>
-            <a:endParaRPr lang="en-US" sz="1400" dirty="0"/>
-          </a:p>
-          <a:p>
-            <a:pPr marL="342900" indent="-342900">
-              <a:buSzPct val="100000"/>
-              <a:buChar char="•"/>
-            </a:pPr>
-            <a:r>
-              <a:rPr lang="en-US" sz="1400" b="1" dirty="0">
-                <a:solidFill>
-                  <a:srgbClr val="2C5F2D"/>
-                </a:solidFill>
-              </a:rPr>
-              <a:t>• Final FPR: 0% (0/103)</a:t>
-            </a:r>
-            <a:endParaRPr lang="en-US" sz="1400" dirty="0"/>
-          </a:p>
-        </p:txBody>
-      </p:sp>
-      <p:sp>
-        <p:nvSpPr>
-          <p:cNvPr id="7" name="Shape 5"/>
-          <p:cNvSpPr/>
-          <p:nvPr/>
-        </p:nvSpPr>
-        <p:spPr>
-          <a:xfrm>
-            <a:off x="1371600" y="3017520"/>
-            <a:ext cx="6400800" cy="640080"/>
-          </a:xfrm>
-          <a:prstGeom prst="rect">
-            <a:avLst/>
-          </a:prstGeom>
-          <a:solidFill>
-            <a:srgbClr val="2C5F2D"/>
-          </a:solidFill>
-          <a:ln/>
-        </p:spPr>
-      </p:sp>
-      <p:sp>
-        <p:nvSpPr>
-          <p:cNvPr id="8" name="Text 6"/>
+        </p:txBody>
+      </p:sp>
+      <p:sp>
+        <p:nvSpPr>
+          <p:cNvPr id="9" name="Text 6"/>
           <p:cNvSpPr txBox="1"/>
           <p:nvPr/>
         </p:nvSpPr>
         <p:spPr>
           <a:xfrm>
-            <a:off x="1554480" y="3154680"/>
-            <a:ext cx="6035040" cy="365760"/>
+            <a:off x="4937760" y="3383280"/>
+            <a:ext cx="3291840" cy="457200"/>
           </a:xfrm>
           <a:prstGeom prst="rect">
             <a:avLst/>
@@ -2858,52 +2779,30 @@
           <a:bodyPr wrap="square" rtlCol="0" anchor="ctr"/>
           <a:lstStyle/>
           <a:p>
-            <a:pPr algn="ctr" indent="0" marL="0">
-              <a:buNone/>
-            </a:pPr>
-            <a:r>
-              <a:rPr lang="en-US" sz="2200" b="1" dirty="0">
-                <a:solidFill>
-                  <a:srgbClr val="FFFFFF"/>
-                </a:solidFill>
-              </a:rPr>
-              <a:t>Perfect Final System: 100% TPR, 0% FPR</a:t>
-            </a:r>
-            <a:endParaRPr lang="en-US" sz="2200" dirty="0"/>
-          </a:p>
-        </p:txBody>
-      </p:sp>
-      <p:sp>
-        <p:nvSpPr>
-          <p:cNvPr id="9" name="Text 7"/>
-          <p:cNvSpPr txBox="1"/>
-          <p:nvPr/>
-        </p:nvSpPr>
-        <p:spPr>
-          <a:xfrm>
-            <a:off x="731520" y="4114800"/>
-            <a:ext cx="7680960" cy="274320"/>
-          </a:xfrm>
-          <a:prstGeom prst="rect">
-            <a:avLst/>
-          </a:prstGeom>
-          <a:noFill/>
-          <a:ln/>
-        </p:spPr>
-        <p:txBody>
-          <a:bodyPr wrap="square" rtlCol="0" anchor="ctr"/>
-          <a:lstStyle/>
-          <a:p>
             <a:pPr indent="0" marL="0">
               <a:buNone/>
             </a:pPr>
             <a:r>
-              <a:rPr lang="en-US" sz="1200" i="1" dirty="0">
+              <a:rPr lang="en-US" sz="1200" dirty="0">
                 <a:solidFill>
                   <a:srgbClr val="2C2C2C"/>
                 </a:solidFill>
               </a:rPr>
-              <a:t>Reference: See Figure 10 (Height Consistency graph)</a:t>
+              <a:t>Conservative rescue criteria</a:t>
+            </a:r>
+            <a:endParaRPr lang="en-US" sz="1200" dirty="0"/>
+          </a:p>
+          <a:p>
+            <a:pPr indent="0" marL="0">
+              <a:buNone/>
+            </a:pPr>
+            <a:r>
+              <a:rPr lang="en-US" sz="1200" dirty="0">
+                <a:solidFill>
+                  <a:srgbClr val="2C2C2C"/>
+                </a:solidFill>
+              </a:rPr>
+              <a:t>Recovering temporal edge cases</a:t>
             </a:r>
             <a:endParaRPr lang="en-US" sz="1200" dirty="0"/>
           </a:p>
@@ -2971,1064 +2870,56 @@
                   <a:srgbClr val="1E2761"/>
                 </a:solidFill>
               </a:rPr>
-              <a:t>Final System Performance</a:t>
+              <a:t>Stage 3: 3D Accuracy Validation</a:t>
             </a:r>
             <a:endParaRPr lang="en-US" sz="3600" dirty="0"/>
           </a:p>
         </p:txBody>
       </p:sp>
-      <p:sp>
-        <p:nvSpPr>
-          <p:cNvPr id="3" name="Text 1"/>
-          <p:cNvSpPr txBox="1"/>
-          <p:nvPr/>
-        </p:nvSpPr>
-        <p:spPr>
-          <a:xfrm>
-            <a:off x="731520" y="1005840"/>
-            <a:ext cx="7680960" cy="274320"/>
-          </a:xfrm>
-          <a:prstGeom prst="rect">
-            <a:avLst/>
-          </a:prstGeom>
-          <a:noFill/>
-          <a:ln/>
-        </p:spPr>
-        <p:txBody>
-          <a:bodyPr wrap="square" rtlCol="0" anchor="ctr"/>
-          <a:lstStyle/>
-          <a:p>
-            <a:pPr indent="0" marL="0">
-              <a:buNone/>
-            </a:pPr>
-            <a:r>
-              <a:rPr lang="en-US" sz="1600" i="1" dirty="0">
-                <a:solidFill>
-                  <a:srgbClr val="2C2C2C"/>
-                </a:solidFill>
-              </a:rPr>
-              <a:t>Test Set (67 frames, 148 objects):</a:t>
-            </a:r>
-            <a:endParaRPr lang="en-US" sz="1600" dirty="0"/>
-          </a:p>
-        </p:txBody>
-      </p:sp>
-      <p:graphicFrame>
-        <p:nvGraphicFramePr>
-          <p:cNvPr id="13" name="Table 0"/>
-          <p:cNvGraphicFramePr>
-            <a:graphicFrameLocks noGrp="1"/>
-          </p:cNvGraphicFramePr>
-          <p:nvPr>
-            <p:extLst>
-              <p:ext uri="{D42A27DB-BD31-4B8C-83A1-F6EECF244321}">
-                <p14:modId xmlns:p14="http://schemas.microsoft.com/office/powerpoint/2010/main" val="1579011935"/>
-              </p:ext>
-            </p:extLst>
-          </p:nvPr>
-        </p:nvGraphicFramePr>
-        <p:xfrm>
-          <a:off x="731520" y="1463040"/>
-          <a:ext cx="7680960" cy="1371600"/>
-        </p:xfrm>
-        <a:graphic>
-          <a:graphicData uri="http://schemas.openxmlformats.org/drawingml/2006/table">
-            <a:tbl>
-              <a:tblPr/>
-              <a:tblGrid>
-                <a:gridCol w="1920240"/>
-                <a:gridCol w="1920240"/>
-                <a:gridCol w="1920240"/>
-                <a:gridCol w="1920240"/>
-              </a:tblGrid>
-              <a:tr h="342900">
-                <a:tc>
-                  <a:txBody>
-                    <a:bodyPr/>
-                    <a:lstStyle/>
-                    <a:p>
-                      <a:pPr algn="ctr" indent="0" marL="0">
-                        <a:buNone/>
-                      </a:pPr>
-                      <a:r>
-                        <a:rPr lang="en-US" sz="1400" dirty="0">
-                          <a:solidFill>
-                            <a:srgbClr val="2C2C2C"/>
-                          </a:solidFill>
-                        </a:rPr>
-                        <a:t>Metric</a:t>
-                      </a:r>
-                      <a:endParaRPr lang="en-US" sz="1400" dirty="0"/>
-                    </a:p>
-                  </a:txBody>
-                  <a:tcPr marL="91440" marR="91440" marT="45720" marB="45720" anchor="ctr">
-                    <a:lnL w="12700" cap="flat" cmpd="sng" algn="ctr">
-                      <a:solidFill>
-                        <a:srgbClr val="1E2761"/>
-                      </a:solidFill>
-                      <a:prstDash val="solid"/>
-                      <a:round/>
-                      <a:headEnd type="none" w="med" len="med"/>
-                      <a:tailEnd type="none" w="med" len="med"/>
-                    </a:lnL>
-                    <a:lnR w="12700" cap="flat" cmpd="sng" algn="ctr">
-                      <a:solidFill>
-                        <a:srgbClr val="1E2761"/>
-                      </a:solidFill>
-                      <a:prstDash val="solid"/>
-                      <a:round/>
-                      <a:headEnd type="none" w="med" len="med"/>
-                      <a:tailEnd type="none" w="med" len="med"/>
-                    </a:lnR>
-                    <a:lnT w="12700" cap="flat" cmpd="sng" algn="ctr">
-                      <a:solidFill>
-                        <a:srgbClr val="1E2761"/>
-                      </a:solidFill>
-                      <a:prstDash val="solid"/>
-                      <a:round/>
-                      <a:headEnd type="none" w="med" len="med"/>
-                      <a:tailEnd type="none" w="med" len="med"/>
-                    </a:lnT>
-                    <a:lnB w="12700" cap="flat" cmpd="sng" algn="ctr">
-                      <a:solidFill>
-                        <a:srgbClr val="1E2761"/>
-                      </a:solidFill>
-                      <a:prstDash val="solid"/>
-                      <a:round/>
-                      <a:headEnd type="none" w="med" len="med"/>
-                      <a:tailEnd type="none" w="med" len="med"/>
-                    </a:lnB>
-                    <a:solidFill>
-                      <a:srgbClr val="F5F5F5"/>
-                    </a:solidFill>
-                  </a:tcPr>
-                </a:tc>
-                <a:tc>
-                  <a:txBody>
-                    <a:bodyPr/>
-                    <a:lstStyle/>
-                    <a:p>
-                      <a:pPr algn="ctr" indent="0" marL="0">
-                        <a:buNone/>
-                      </a:pPr>
-                      <a:r>
-                        <a:rPr lang="en-US" sz="1400" dirty="0">
-                          <a:solidFill>
-                            <a:srgbClr val="2C2C2C"/>
-                          </a:solidFill>
-                        </a:rPr>
-                        <a:t>Target</a:t>
-                      </a:r>
-                      <a:endParaRPr lang="en-US" sz="1400" dirty="0"/>
-                    </a:p>
-                  </a:txBody>
-                  <a:tcPr marL="91440" marR="91440" marT="45720" marB="45720" anchor="ctr">
-                    <a:lnL w="12700" cap="flat" cmpd="sng" algn="ctr">
-                      <a:solidFill>
-                        <a:srgbClr val="1E2761"/>
-                      </a:solidFill>
-                      <a:prstDash val="solid"/>
-                      <a:round/>
-                      <a:headEnd type="none" w="med" len="med"/>
-                      <a:tailEnd type="none" w="med" len="med"/>
-                    </a:lnL>
-                    <a:lnR w="12700" cap="flat" cmpd="sng" algn="ctr">
-                      <a:solidFill>
-                        <a:srgbClr val="1E2761"/>
-                      </a:solidFill>
-                      <a:prstDash val="solid"/>
-                      <a:round/>
-                      <a:headEnd type="none" w="med" len="med"/>
-                      <a:tailEnd type="none" w="med" len="med"/>
-                    </a:lnR>
-                    <a:lnT w="12700" cap="flat" cmpd="sng" algn="ctr">
-                      <a:solidFill>
-                        <a:srgbClr val="1E2761"/>
-                      </a:solidFill>
-                      <a:prstDash val="solid"/>
-                      <a:round/>
-                      <a:headEnd type="none" w="med" len="med"/>
-                      <a:tailEnd type="none" w="med" len="med"/>
-                    </a:lnT>
-                    <a:lnB w="12700" cap="flat" cmpd="sng" algn="ctr">
-                      <a:solidFill>
-                        <a:srgbClr val="1E2761"/>
-                      </a:solidFill>
-                      <a:prstDash val="solid"/>
-                      <a:round/>
-                      <a:headEnd type="none" w="med" len="med"/>
-                      <a:tailEnd type="none" w="med" len="med"/>
-                    </a:lnB>
-                    <a:solidFill>
-                      <a:srgbClr val="F5F5F5"/>
-                    </a:solidFill>
-                  </a:tcPr>
-                </a:tc>
-                <a:tc>
-                  <a:txBody>
-                    <a:bodyPr/>
-                    <a:lstStyle/>
-                    <a:p>
-                      <a:pPr algn="ctr" indent="0" marL="0">
-                        <a:buNone/>
-                      </a:pPr>
-                      <a:r>
-                        <a:rPr lang="en-US" sz="1400" dirty="0">
-                          <a:solidFill>
-                            <a:srgbClr val="2C2C2C"/>
-                          </a:solidFill>
-                        </a:rPr>
-                        <a:t>Achieved</a:t>
-                      </a:r>
-                      <a:endParaRPr lang="en-US" sz="1400" dirty="0"/>
-                    </a:p>
-                  </a:txBody>
-                  <a:tcPr marL="91440" marR="91440" marT="45720" marB="45720" anchor="ctr">
-                    <a:lnL w="12700" cap="flat" cmpd="sng" algn="ctr">
-                      <a:solidFill>
-                        <a:srgbClr val="1E2761"/>
-                      </a:solidFill>
-                      <a:prstDash val="solid"/>
-                      <a:round/>
-                      <a:headEnd type="none" w="med" len="med"/>
-                      <a:tailEnd type="none" w="med" len="med"/>
-                    </a:lnL>
-                    <a:lnR w="12700" cap="flat" cmpd="sng" algn="ctr">
-                      <a:solidFill>
-                        <a:srgbClr val="1E2761"/>
-                      </a:solidFill>
-                      <a:prstDash val="solid"/>
-                      <a:round/>
-                      <a:headEnd type="none" w="med" len="med"/>
-                      <a:tailEnd type="none" w="med" len="med"/>
-                    </a:lnR>
-                    <a:lnT w="12700" cap="flat" cmpd="sng" algn="ctr">
-                      <a:solidFill>
-                        <a:srgbClr val="1E2761"/>
-                      </a:solidFill>
-                      <a:prstDash val="solid"/>
-                      <a:round/>
-                      <a:headEnd type="none" w="med" len="med"/>
-                      <a:tailEnd type="none" w="med" len="med"/>
-                    </a:lnT>
-                    <a:lnB w="12700" cap="flat" cmpd="sng" algn="ctr">
-                      <a:solidFill>
-                        <a:srgbClr val="1E2761"/>
-                      </a:solidFill>
-                      <a:prstDash val="solid"/>
-                      <a:round/>
-                      <a:headEnd type="none" w="med" len="med"/>
-                      <a:tailEnd type="none" w="med" len="med"/>
-                    </a:lnB>
-                    <a:solidFill>
-                      <a:srgbClr val="F5F5F5"/>
-                    </a:solidFill>
-                  </a:tcPr>
-                </a:tc>
-                <a:tc>
-                  <a:txBody>
-                    <a:bodyPr/>
-                    <a:lstStyle/>
-                    <a:p>
-                      <a:pPr algn="ctr" indent="0" marL="0">
-                        <a:buNone/>
-                      </a:pPr>
-                      <a:r>
-                        <a:rPr lang="en-US" sz="1400" dirty="0">
-                          <a:solidFill>
-                            <a:srgbClr val="2C2C2C"/>
-                          </a:solidFill>
-                        </a:rPr>
-                        <a:t>Status</a:t>
-                      </a:r>
-                      <a:endParaRPr lang="en-US" sz="1400" dirty="0"/>
-                    </a:p>
-                  </a:txBody>
-                  <a:tcPr marL="91440" marR="91440" marT="45720" marB="45720" anchor="ctr">
-                    <a:lnL w="12700" cap="flat" cmpd="sng" algn="ctr">
-                      <a:solidFill>
-                        <a:srgbClr val="1E2761"/>
-                      </a:solidFill>
-                      <a:prstDash val="solid"/>
-                      <a:round/>
-                      <a:headEnd type="none" w="med" len="med"/>
-                      <a:tailEnd type="none" w="med" len="med"/>
-                    </a:lnL>
-                    <a:lnR w="12700" cap="flat" cmpd="sng" algn="ctr">
-                      <a:solidFill>
-                        <a:srgbClr val="1E2761"/>
-                      </a:solidFill>
-                      <a:prstDash val="solid"/>
-                      <a:round/>
-                      <a:headEnd type="none" w="med" len="med"/>
-                      <a:tailEnd type="none" w="med" len="med"/>
-                    </a:lnR>
-                    <a:lnT w="12700" cap="flat" cmpd="sng" algn="ctr">
-                      <a:solidFill>
-                        <a:srgbClr val="1E2761"/>
-                      </a:solidFill>
-                      <a:prstDash val="solid"/>
-                      <a:round/>
-                      <a:headEnd type="none" w="med" len="med"/>
-                      <a:tailEnd type="none" w="med" len="med"/>
-                    </a:lnT>
-                    <a:lnB w="12700" cap="flat" cmpd="sng" algn="ctr">
-                      <a:solidFill>
-                        <a:srgbClr val="1E2761"/>
-                      </a:solidFill>
-                      <a:prstDash val="solid"/>
-                      <a:round/>
-                      <a:headEnd type="none" w="med" len="med"/>
-                      <a:tailEnd type="none" w="med" len="med"/>
-                    </a:lnB>
-                    <a:solidFill>
-                      <a:srgbClr val="F5F5F5"/>
-                    </a:solidFill>
-                  </a:tcPr>
-                </a:tc>
-              </a:tr>
-              <a:tr h="342900">
-                <a:tc>
-                  <a:txBody>
-                    <a:bodyPr/>
-                    <a:lstStyle/>
-                    <a:p>
-                      <a:pPr algn="ctr" indent="0" marL="0">
-                        <a:buNone/>
-                      </a:pPr>
-                      <a:r>
-                        <a:rPr lang="en-US" sz="1400" dirty="0">
-                          <a:solidFill>
-                            <a:srgbClr val="2C2C2C"/>
-                          </a:solidFill>
-                        </a:rPr>
-                        <a:t>Real-object TPR</a:t>
-                      </a:r>
-                      <a:endParaRPr lang="en-US" sz="1400" dirty="0"/>
-                    </a:p>
-                  </a:txBody>
-                  <a:tcPr marL="91440" marR="91440" marT="45720" marB="45720" anchor="ctr">
-                    <a:lnL w="12700" cap="flat" cmpd="sng" algn="ctr">
-                      <a:solidFill>
-                        <a:srgbClr val="1E2761"/>
-                      </a:solidFill>
-                      <a:prstDash val="solid"/>
-                      <a:round/>
-                      <a:headEnd type="none" w="med" len="med"/>
-                      <a:tailEnd type="none" w="med" len="med"/>
-                    </a:lnL>
-                    <a:lnR w="12700" cap="flat" cmpd="sng" algn="ctr">
-                      <a:solidFill>
-                        <a:srgbClr val="1E2761"/>
-                      </a:solidFill>
-                      <a:prstDash val="solid"/>
-                      <a:round/>
-                      <a:headEnd type="none" w="med" len="med"/>
-                      <a:tailEnd type="none" w="med" len="med"/>
-                    </a:lnR>
-                    <a:lnT w="12700" cap="flat" cmpd="sng" algn="ctr">
-                      <a:solidFill>
-                        <a:srgbClr val="1E2761"/>
-                      </a:solidFill>
-                      <a:prstDash val="solid"/>
-                      <a:round/>
-                      <a:headEnd type="none" w="med" len="med"/>
-                      <a:tailEnd type="none" w="med" len="med"/>
-                    </a:lnT>
-                    <a:lnB w="12700" cap="flat" cmpd="sng" algn="ctr">
-                      <a:solidFill>
-                        <a:srgbClr val="1E2761"/>
-                      </a:solidFill>
-                      <a:prstDash val="solid"/>
-                      <a:round/>
-                      <a:headEnd type="none" w="med" len="med"/>
-                      <a:tailEnd type="none" w="med" len="med"/>
-                    </a:lnB>
-                    <a:solidFill>
-                      <a:srgbClr val="F5F5F5"/>
-                    </a:solidFill>
-                  </a:tcPr>
-                </a:tc>
-                <a:tc>
-                  <a:txBody>
-                    <a:bodyPr/>
-                    <a:lstStyle/>
-                    <a:p>
-                      <a:pPr algn="ctr" indent="0" marL="0">
-                        <a:buNone/>
-                      </a:pPr>
-                      <a:r>
-                        <a:rPr lang="en-US" sz="1400" dirty="0">
-                          <a:solidFill>
-                            <a:srgbClr val="2C2C2C"/>
-                          </a:solidFill>
-                        </a:rPr>
-                        <a:t>≥75%</a:t>
-                      </a:r>
-                      <a:endParaRPr lang="en-US" sz="1400" dirty="0"/>
-                    </a:p>
-                  </a:txBody>
-                  <a:tcPr marL="91440" marR="91440" marT="45720" marB="45720" anchor="ctr">
-                    <a:lnL w="12700" cap="flat" cmpd="sng" algn="ctr">
-                      <a:solidFill>
-                        <a:srgbClr val="1E2761"/>
-                      </a:solidFill>
-                      <a:prstDash val="solid"/>
-                      <a:round/>
-                      <a:headEnd type="none" w="med" len="med"/>
-                      <a:tailEnd type="none" w="med" len="med"/>
-                    </a:lnL>
-                    <a:lnR w="12700" cap="flat" cmpd="sng" algn="ctr">
-                      <a:solidFill>
-                        <a:srgbClr val="1E2761"/>
-                      </a:solidFill>
-                      <a:prstDash val="solid"/>
-                      <a:round/>
-                      <a:headEnd type="none" w="med" len="med"/>
-                      <a:tailEnd type="none" w="med" len="med"/>
-                    </a:lnR>
-                    <a:lnT w="12700" cap="flat" cmpd="sng" algn="ctr">
-                      <a:solidFill>
-                        <a:srgbClr val="1E2761"/>
-                      </a:solidFill>
-                      <a:prstDash val="solid"/>
-                      <a:round/>
-                      <a:headEnd type="none" w="med" len="med"/>
-                      <a:tailEnd type="none" w="med" len="med"/>
-                    </a:lnT>
-                    <a:lnB w="12700" cap="flat" cmpd="sng" algn="ctr">
-                      <a:solidFill>
-                        <a:srgbClr val="1E2761"/>
-                      </a:solidFill>
-                      <a:prstDash val="solid"/>
-                      <a:round/>
-                      <a:headEnd type="none" w="med" len="med"/>
-                      <a:tailEnd type="none" w="med" len="med"/>
-                    </a:lnB>
-                    <a:solidFill>
-                      <a:srgbClr val="F5F5F5"/>
-                    </a:solidFill>
-                  </a:tcPr>
-                </a:tc>
-                <a:tc>
-                  <a:txBody>
-                    <a:bodyPr/>
-                    <a:lstStyle/>
-                    <a:p>
-                      <a:pPr algn="ctr" indent="0" marL="0">
-                        <a:buNone/>
-                      </a:pPr>
-                      <a:r>
-                        <a:rPr lang="en-US" sz="1400" dirty="0">
-                          <a:solidFill>
-                            <a:srgbClr val="2C2C2C"/>
-                          </a:solidFill>
-                        </a:rPr>
-                        <a:t>100%</a:t>
-                      </a:r>
-                      <a:endParaRPr lang="en-US" sz="1400" dirty="0"/>
-                    </a:p>
-                  </a:txBody>
-                  <a:tcPr marL="91440" marR="91440" marT="45720" marB="45720" anchor="ctr">
-                    <a:lnL w="12700" cap="flat" cmpd="sng" algn="ctr">
-                      <a:solidFill>
-                        <a:srgbClr val="1E2761"/>
-                      </a:solidFill>
-                      <a:prstDash val="solid"/>
-                      <a:round/>
-                      <a:headEnd type="none" w="med" len="med"/>
-                      <a:tailEnd type="none" w="med" len="med"/>
-                    </a:lnL>
-                    <a:lnR w="12700" cap="flat" cmpd="sng" algn="ctr">
-                      <a:solidFill>
-                        <a:srgbClr val="1E2761"/>
-                      </a:solidFill>
-                      <a:prstDash val="solid"/>
-                      <a:round/>
-                      <a:headEnd type="none" w="med" len="med"/>
-                      <a:tailEnd type="none" w="med" len="med"/>
-                    </a:lnR>
-                    <a:lnT w="12700" cap="flat" cmpd="sng" algn="ctr">
-                      <a:solidFill>
-                        <a:srgbClr val="1E2761"/>
-                      </a:solidFill>
-                      <a:prstDash val="solid"/>
-                      <a:round/>
-                      <a:headEnd type="none" w="med" len="med"/>
-                      <a:tailEnd type="none" w="med" len="med"/>
-                    </a:lnT>
-                    <a:lnB w="12700" cap="flat" cmpd="sng" algn="ctr">
-                      <a:solidFill>
-                        <a:srgbClr val="1E2761"/>
-                      </a:solidFill>
-                      <a:prstDash val="solid"/>
-                      <a:round/>
-                      <a:headEnd type="none" w="med" len="med"/>
-                      <a:tailEnd type="none" w="med" len="med"/>
-                    </a:lnB>
-                    <a:solidFill>
-                      <a:srgbClr val="F5F5F5"/>
-                    </a:solidFill>
-                  </a:tcPr>
-                </a:tc>
-                <a:tc>
-                  <a:txBody>
-                    <a:bodyPr/>
-                    <a:lstStyle/>
-                    <a:p>
-                      <a:pPr algn="ctr" indent="0" marL="0">
-                        <a:buNone/>
-                      </a:pPr>
-                      <a:r>
-                        <a:rPr lang="en-US" sz="1400" dirty="0">
-                          <a:solidFill>
-                            <a:srgbClr val="2C2C2C"/>
-                          </a:solidFill>
-                        </a:rPr>
-                        <a:t>+25 points!</a:t>
-                      </a:r>
-                      <a:endParaRPr lang="en-US" sz="1400" dirty="0"/>
-                    </a:p>
-                  </a:txBody>
-                  <a:tcPr marL="91440" marR="91440" marT="45720" marB="45720" anchor="ctr">
-                    <a:lnL w="12700" cap="flat" cmpd="sng" algn="ctr">
-                      <a:solidFill>
-                        <a:srgbClr val="1E2761"/>
-                      </a:solidFill>
-                      <a:prstDash val="solid"/>
-                      <a:round/>
-                      <a:headEnd type="none" w="med" len="med"/>
-                      <a:tailEnd type="none" w="med" len="med"/>
-                    </a:lnL>
-                    <a:lnR w="12700" cap="flat" cmpd="sng" algn="ctr">
-                      <a:solidFill>
-                        <a:srgbClr val="1E2761"/>
-                      </a:solidFill>
-                      <a:prstDash val="solid"/>
-                      <a:round/>
-                      <a:headEnd type="none" w="med" len="med"/>
-                      <a:tailEnd type="none" w="med" len="med"/>
-                    </a:lnR>
-                    <a:lnT w="12700" cap="flat" cmpd="sng" algn="ctr">
-                      <a:solidFill>
-                        <a:srgbClr val="1E2761"/>
-                      </a:solidFill>
-                      <a:prstDash val="solid"/>
-                      <a:round/>
-                      <a:headEnd type="none" w="med" len="med"/>
-                      <a:tailEnd type="none" w="med" len="med"/>
-                    </a:lnT>
-                    <a:lnB w="12700" cap="flat" cmpd="sng" algn="ctr">
-                      <a:solidFill>
-                        <a:srgbClr val="1E2761"/>
-                      </a:solidFill>
-                      <a:prstDash val="solid"/>
-                      <a:round/>
-                      <a:headEnd type="none" w="med" len="med"/>
-                      <a:tailEnd type="none" w="med" len="med"/>
-                    </a:lnB>
-                    <a:solidFill>
-                      <a:srgbClr val="F5F5F5"/>
-                    </a:solidFill>
-                  </a:tcPr>
-                </a:tc>
-              </a:tr>
-              <a:tr h="342900">
-                <a:tc>
-                  <a:txBody>
-                    <a:bodyPr/>
-                    <a:lstStyle/>
-                    <a:p>
-                      <a:pPr algn="ctr" indent="0" marL="0">
-                        <a:buNone/>
-                      </a:pPr>
-                      <a:r>
-                        <a:rPr lang="en-US" sz="1400" dirty="0">
-                          <a:solidFill>
-                            <a:srgbClr val="2C2C2C"/>
-                          </a:solidFill>
-                        </a:rPr>
-                        <a:t>Decoy FPR</a:t>
-                      </a:r>
-                      <a:endParaRPr lang="en-US" sz="1400" dirty="0"/>
-                    </a:p>
-                  </a:txBody>
-                  <a:tcPr marL="91440" marR="91440" marT="45720" marB="45720" anchor="ctr">
-                    <a:lnL w="12700" cap="flat" cmpd="sng" algn="ctr">
-                      <a:solidFill>
-                        <a:srgbClr val="1E2761"/>
-                      </a:solidFill>
-                      <a:prstDash val="solid"/>
-                      <a:round/>
-                      <a:headEnd type="none" w="med" len="med"/>
-                      <a:tailEnd type="none" w="med" len="med"/>
-                    </a:lnL>
-                    <a:lnR w="12700" cap="flat" cmpd="sng" algn="ctr">
-                      <a:solidFill>
-                        <a:srgbClr val="1E2761"/>
-                      </a:solidFill>
-                      <a:prstDash val="solid"/>
-                      <a:round/>
-                      <a:headEnd type="none" w="med" len="med"/>
-                      <a:tailEnd type="none" w="med" len="med"/>
-                    </a:lnR>
-                    <a:lnT w="12700" cap="flat" cmpd="sng" algn="ctr">
-                      <a:solidFill>
-                        <a:srgbClr val="1E2761"/>
-                      </a:solidFill>
-                      <a:prstDash val="solid"/>
-                      <a:round/>
-                      <a:headEnd type="none" w="med" len="med"/>
-                      <a:tailEnd type="none" w="med" len="med"/>
-                    </a:lnT>
-                    <a:lnB w="12700" cap="flat" cmpd="sng" algn="ctr">
-                      <a:solidFill>
-                        <a:srgbClr val="1E2761"/>
-                      </a:solidFill>
-                      <a:prstDash val="solid"/>
-                      <a:round/>
-                      <a:headEnd type="none" w="med" len="med"/>
-                      <a:tailEnd type="none" w="med" len="med"/>
-                    </a:lnB>
-                    <a:solidFill>
-                      <a:srgbClr val="F5F5F5"/>
-                    </a:solidFill>
-                  </a:tcPr>
-                </a:tc>
-                <a:tc>
-                  <a:txBody>
-                    <a:bodyPr/>
-                    <a:lstStyle/>
-                    <a:p>
-                      <a:pPr algn="ctr" indent="0" marL="0">
-                        <a:buNone/>
-                      </a:pPr>
-                      <a:r>
-                        <a:rPr lang="en-US" sz="1400" dirty="0">
-                          <a:solidFill>
-                            <a:srgbClr val="2C2C2C"/>
-                          </a:solidFill>
-                        </a:rPr>
-                        <a:t>≤15%</a:t>
-                      </a:r>
-                      <a:endParaRPr lang="en-US" sz="1400" dirty="0"/>
-                    </a:p>
-                  </a:txBody>
-                  <a:tcPr marL="91440" marR="91440" marT="45720" marB="45720" anchor="ctr">
-                    <a:lnL w="12700" cap="flat" cmpd="sng" algn="ctr">
-                      <a:solidFill>
-                        <a:srgbClr val="1E2761"/>
-                      </a:solidFill>
-                      <a:prstDash val="solid"/>
-                      <a:round/>
-                      <a:headEnd type="none" w="med" len="med"/>
-                      <a:tailEnd type="none" w="med" len="med"/>
-                    </a:lnL>
-                    <a:lnR w="12700" cap="flat" cmpd="sng" algn="ctr">
-                      <a:solidFill>
-                        <a:srgbClr val="1E2761"/>
-                      </a:solidFill>
-                      <a:prstDash val="solid"/>
-                      <a:round/>
-                      <a:headEnd type="none" w="med" len="med"/>
-                      <a:tailEnd type="none" w="med" len="med"/>
-                    </a:lnR>
-                    <a:lnT w="12700" cap="flat" cmpd="sng" algn="ctr">
-                      <a:solidFill>
-                        <a:srgbClr val="1E2761"/>
-                      </a:solidFill>
-                      <a:prstDash val="solid"/>
-                      <a:round/>
-                      <a:headEnd type="none" w="med" len="med"/>
-                      <a:tailEnd type="none" w="med" len="med"/>
-                    </a:lnT>
-                    <a:lnB w="12700" cap="flat" cmpd="sng" algn="ctr">
-                      <a:solidFill>
-                        <a:srgbClr val="1E2761"/>
-                      </a:solidFill>
-                      <a:prstDash val="solid"/>
-                      <a:round/>
-                      <a:headEnd type="none" w="med" len="med"/>
-                      <a:tailEnd type="none" w="med" len="med"/>
-                    </a:lnB>
-                    <a:solidFill>
-                      <a:srgbClr val="F5F5F5"/>
-                    </a:solidFill>
-                  </a:tcPr>
-                </a:tc>
-                <a:tc>
-                  <a:txBody>
-                    <a:bodyPr/>
-                    <a:lstStyle/>
-                    <a:p>
-                      <a:pPr algn="ctr" indent="0" marL="0">
-                        <a:buNone/>
-                      </a:pPr>
-                      <a:r>
-                        <a:rPr lang="en-US" sz="1400" dirty="0">
-                          <a:solidFill>
-                            <a:srgbClr val="2C2C2C"/>
-                          </a:solidFill>
-                        </a:rPr>
-                        <a:t>0%</a:t>
-                      </a:r>
-                      <a:endParaRPr lang="en-US" sz="1400" dirty="0"/>
-                    </a:p>
-                  </a:txBody>
-                  <a:tcPr marL="91440" marR="91440" marT="45720" marB="45720" anchor="ctr">
-                    <a:lnL w="12700" cap="flat" cmpd="sng" algn="ctr">
-                      <a:solidFill>
-                        <a:srgbClr val="1E2761"/>
-                      </a:solidFill>
-                      <a:prstDash val="solid"/>
-                      <a:round/>
-                      <a:headEnd type="none" w="med" len="med"/>
-                      <a:tailEnd type="none" w="med" len="med"/>
-                    </a:lnL>
-                    <a:lnR w="12700" cap="flat" cmpd="sng" algn="ctr">
-                      <a:solidFill>
-                        <a:srgbClr val="1E2761"/>
-                      </a:solidFill>
-                      <a:prstDash val="solid"/>
-                      <a:round/>
-                      <a:headEnd type="none" w="med" len="med"/>
-                      <a:tailEnd type="none" w="med" len="med"/>
-                    </a:lnR>
-                    <a:lnT w="12700" cap="flat" cmpd="sng" algn="ctr">
-                      <a:solidFill>
-                        <a:srgbClr val="1E2761"/>
-                      </a:solidFill>
-                      <a:prstDash val="solid"/>
-                      <a:round/>
-                      <a:headEnd type="none" w="med" len="med"/>
-                      <a:tailEnd type="none" w="med" len="med"/>
-                    </a:lnT>
-                    <a:lnB w="12700" cap="flat" cmpd="sng" algn="ctr">
-                      <a:solidFill>
-                        <a:srgbClr val="1E2761"/>
-                      </a:solidFill>
-                      <a:prstDash val="solid"/>
-                      <a:round/>
-                      <a:headEnd type="none" w="med" len="med"/>
-                      <a:tailEnd type="none" w="med" len="med"/>
-                    </a:lnB>
-                    <a:solidFill>
-                      <a:srgbClr val="F5F5F5"/>
-                    </a:solidFill>
-                  </a:tcPr>
-                </a:tc>
-                <a:tc>
-                  <a:txBody>
-                    <a:bodyPr/>
-                    <a:lstStyle/>
-                    <a:p>
-                      <a:pPr algn="ctr" indent="0" marL="0">
-                        <a:buNone/>
-                      </a:pPr>
-                      <a:r>
-                        <a:rPr lang="en-US" sz="1400" dirty="0">
-                          <a:solidFill>
-                            <a:srgbClr val="2C2C2C"/>
-                          </a:solidFill>
-                        </a:rPr>
-                        <a:t>+15 points!</a:t>
-                      </a:r>
-                      <a:endParaRPr lang="en-US" sz="1400" dirty="0"/>
-                    </a:p>
-                  </a:txBody>
-                  <a:tcPr marL="91440" marR="91440" marT="45720" marB="45720" anchor="ctr">
-                    <a:lnL w="12700" cap="flat" cmpd="sng" algn="ctr">
-                      <a:solidFill>
-                        <a:srgbClr val="1E2761"/>
-                      </a:solidFill>
-                      <a:prstDash val="solid"/>
-                      <a:round/>
-                      <a:headEnd type="none" w="med" len="med"/>
-                      <a:tailEnd type="none" w="med" len="med"/>
-                    </a:lnL>
-                    <a:lnR w="12700" cap="flat" cmpd="sng" algn="ctr">
-                      <a:solidFill>
-                        <a:srgbClr val="1E2761"/>
-                      </a:solidFill>
-                      <a:prstDash val="solid"/>
-                      <a:round/>
-                      <a:headEnd type="none" w="med" len="med"/>
-                      <a:tailEnd type="none" w="med" len="med"/>
-                    </a:lnR>
-                    <a:lnT w="12700" cap="flat" cmpd="sng" algn="ctr">
-                      <a:solidFill>
-                        <a:srgbClr val="1E2761"/>
-                      </a:solidFill>
-                      <a:prstDash val="solid"/>
-                      <a:round/>
-                      <a:headEnd type="none" w="med" len="med"/>
-                      <a:tailEnd type="none" w="med" len="med"/>
-                    </a:lnT>
-                    <a:lnB w="12700" cap="flat" cmpd="sng" algn="ctr">
-                      <a:solidFill>
-                        <a:srgbClr val="1E2761"/>
-                      </a:solidFill>
-                      <a:prstDash val="solid"/>
-                      <a:round/>
-                      <a:headEnd type="none" w="med" len="med"/>
-                      <a:tailEnd type="none" w="med" len="med"/>
-                    </a:lnB>
-                    <a:solidFill>
-                      <a:srgbClr val="F5F5F5"/>
-                    </a:solidFill>
-                  </a:tcPr>
-                </a:tc>
-              </a:tr>
-              <a:tr h="342900">
-                <a:tc>
-                  <a:txBody>
-                    <a:bodyPr/>
-                    <a:lstStyle/>
-                    <a:p>
-                      <a:pPr algn="ctr" indent="0" marL="0">
-                        <a:buNone/>
-                      </a:pPr>
-                      <a:r>
-                        <a:rPr lang="en-US" sz="1400" dirty="0">
-                          <a:solidFill>
-                            <a:srgbClr val="2C2C2C"/>
-                          </a:solidFill>
-                        </a:rPr>
-                        <a:t>Speed</a:t>
-                      </a:r>
-                      <a:endParaRPr lang="en-US" sz="1400" dirty="0"/>
-                    </a:p>
-                  </a:txBody>
-                  <a:tcPr marL="91440" marR="91440" marT="45720" marB="45720" anchor="ctr">
-                    <a:lnL w="12700" cap="flat" cmpd="sng" algn="ctr">
-                      <a:solidFill>
-                        <a:srgbClr val="1E2761"/>
-                      </a:solidFill>
-                      <a:prstDash val="solid"/>
-                      <a:round/>
-                      <a:headEnd type="none" w="med" len="med"/>
-                      <a:tailEnd type="none" w="med" len="med"/>
-                    </a:lnL>
-                    <a:lnR w="12700" cap="flat" cmpd="sng" algn="ctr">
-                      <a:solidFill>
-                        <a:srgbClr val="1E2761"/>
-                      </a:solidFill>
-                      <a:prstDash val="solid"/>
-                      <a:round/>
-                      <a:headEnd type="none" w="med" len="med"/>
-                      <a:tailEnd type="none" w="med" len="med"/>
-                    </a:lnR>
-                    <a:lnT w="12700" cap="flat" cmpd="sng" algn="ctr">
-                      <a:solidFill>
-                        <a:srgbClr val="1E2761"/>
-                      </a:solidFill>
-                      <a:prstDash val="solid"/>
-                      <a:round/>
-                      <a:headEnd type="none" w="med" len="med"/>
-                      <a:tailEnd type="none" w="med" len="med"/>
-                    </a:lnT>
-                    <a:lnB w="12700" cap="flat" cmpd="sng" algn="ctr">
-                      <a:solidFill>
-                        <a:srgbClr val="1E2761"/>
-                      </a:solidFill>
-                      <a:prstDash val="solid"/>
-                      <a:round/>
-                      <a:headEnd type="none" w="med" len="med"/>
-                      <a:tailEnd type="none" w="med" len="med"/>
-                    </a:lnB>
-                    <a:solidFill>
-                      <a:srgbClr val="F5F5F5"/>
-                    </a:solidFill>
-                  </a:tcPr>
-                </a:tc>
-                <a:tc>
-                  <a:txBody>
-                    <a:bodyPr/>
-                    <a:lstStyle/>
-                    <a:p>
-                      <a:pPr algn="ctr" indent="0" marL="0">
-                        <a:buNone/>
-                      </a:pPr>
-                      <a:r>
-                        <a:rPr lang="en-US" sz="1400" dirty="0">
-                          <a:solidFill>
-                            <a:srgbClr val="2C2C2C"/>
-                          </a:solidFill>
-                        </a:rPr>
-                        <a:t>≥30 FPS</a:t>
-                      </a:r>
-                      <a:endParaRPr lang="en-US" sz="1400" dirty="0"/>
-                    </a:p>
-                  </a:txBody>
-                  <a:tcPr marL="91440" marR="91440" marT="45720" marB="45720" anchor="ctr">
-                    <a:lnL w="12700" cap="flat" cmpd="sng" algn="ctr">
-                      <a:solidFill>
-                        <a:srgbClr val="1E2761"/>
-                      </a:solidFill>
-                      <a:prstDash val="solid"/>
-                      <a:round/>
-                      <a:headEnd type="none" w="med" len="med"/>
-                      <a:tailEnd type="none" w="med" len="med"/>
-                    </a:lnL>
-                    <a:lnR w="12700" cap="flat" cmpd="sng" algn="ctr">
-                      <a:solidFill>
-                        <a:srgbClr val="1E2761"/>
-                      </a:solidFill>
-                      <a:prstDash val="solid"/>
-                      <a:round/>
-                      <a:headEnd type="none" w="med" len="med"/>
-                      <a:tailEnd type="none" w="med" len="med"/>
-                    </a:lnR>
-                    <a:lnT w="12700" cap="flat" cmpd="sng" algn="ctr">
-                      <a:solidFill>
-                        <a:srgbClr val="1E2761"/>
-                      </a:solidFill>
-                      <a:prstDash val="solid"/>
-                      <a:round/>
-                      <a:headEnd type="none" w="med" len="med"/>
-                      <a:tailEnd type="none" w="med" len="med"/>
-                    </a:lnT>
-                    <a:lnB w="12700" cap="flat" cmpd="sng" algn="ctr">
-                      <a:solidFill>
-                        <a:srgbClr val="1E2761"/>
-                      </a:solidFill>
-                      <a:prstDash val="solid"/>
-                      <a:round/>
-                      <a:headEnd type="none" w="med" len="med"/>
-                      <a:tailEnd type="none" w="med" len="med"/>
-                    </a:lnB>
-                    <a:solidFill>
-                      <a:srgbClr val="F5F5F5"/>
-                    </a:solidFill>
-                  </a:tcPr>
-                </a:tc>
-                <a:tc>
-                  <a:txBody>
-                    <a:bodyPr/>
-                    <a:lstStyle/>
-                    <a:p>
-                      <a:pPr algn="ctr" indent="0" marL="0">
-                        <a:buNone/>
-                      </a:pPr>
-                      <a:r>
-                        <a:rPr lang="en-US" sz="1400" dirty="0">
-                          <a:solidFill>
-                            <a:srgbClr val="2C2C2C"/>
-                          </a:solidFill>
-                        </a:rPr>
-                        <a:t>66 FPS</a:t>
-                      </a:r>
-                      <a:endParaRPr lang="en-US" sz="1400" dirty="0"/>
-                    </a:p>
-                  </a:txBody>
-                  <a:tcPr marL="91440" marR="91440" marT="45720" marB="45720" anchor="ctr">
-                    <a:lnL w="12700" cap="flat" cmpd="sng" algn="ctr">
-                      <a:solidFill>
-                        <a:srgbClr val="1E2761"/>
-                      </a:solidFill>
-                      <a:prstDash val="solid"/>
-                      <a:round/>
-                      <a:headEnd type="none" w="med" len="med"/>
-                      <a:tailEnd type="none" w="med" len="med"/>
-                    </a:lnL>
-                    <a:lnR w="12700" cap="flat" cmpd="sng" algn="ctr">
-                      <a:solidFill>
-                        <a:srgbClr val="1E2761"/>
-                      </a:solidFill>
-                      <a:prstDash val="solid"/>
-                      <a:round/>
-                      <a:headEnd type="none" w="med" len="med"/>
-                      <a:tailEnd type="none" w="med" len="med"/>
-                    </a:lnR>
-                    <a:lnT w="12700" cap="flat" cmpd="sng" algn="ctr">
-                      <a:solidFill>
-                        <a:srgbClr val="1E2761"/>
-                      </a:solidFill>
-                      <a:prstDash val="solid"/>
-                      <a:round/>
-                      <a:headEnd type="none" w="med" len="med"/>
-                      <a:tailEnd type="none" w="med" len="med"/>
-                    </a:lnT>
-                    <a:lnB w="12700" cap="flat" cmpd="sng" algn="ctr">
-                      <a:solidFill>
-                        <a:srgbClr val="1E2761"/>
-                      </a:solidFill>
-                      <a:prstDash val="solid"/>
-                      <a:round/>
-                      <a:headEnd type="none" w="med" len="med"/>
-                      <a:tailEnd type="none" w="med" len="med"/>
-                    </a:lnB>
-                    <a:solidFill>
-                      <a:srgbClr val="F5F5F5"/>
-                    </a:solidFill>
-                  </a:tcPr>
-                </a:tc>
-                <a:tc>
-                  <a:txBody>
-                    <a:bodyPr/>
-                    <a:lstStyle/>
-                    <a:p>
-                      <a:pPr algn="ctr" indent="0" marL="0">
-                        <a:buNone/>
-                      </a:pPr>
-                      <a:r>
-                        <a:rPr lang="en-US" sz="1400" dirty="0">
-                          <a:solidFill>
-                            <a:srgbClr val="2C2C2C"/>
-                          </a:solidFill>
-                        </a:rPr>
-                        <a:t>✓</a:t>
-                      </a:r>
-                      <a:endParaRPr lang="en-US" sz="1400" dirty="0"/>
-                    </a:p>
-                  </a:txBody>
-                  <a:tcPr marL="91440" marR="91440" marT="45720" marB="45720" anchor="ctr">
-                    <a:lnL w="12700" cap="flat" cmpd="sng" algn="ctr">
-                      <a:solidFill>
-                        <a:srgbClr val="1E2761"/>
-                      </a:solidFill>
-                      <a:prstDash val="solid"/>
-                      <a:round/>
-                      <a:headEnd type="none" w="med" len="med"/>
-                      <a:tailEnd type="none" w="med" len="med"/>
-                    </a:lnL>
-                    <a:lnR w="12700" cap="flat" cmpd="sng" algn="ctr">
-                      <a:solidFill>
-                        <a:srgbClr val="1E2761"/>
-                      </a:solidFill>
-                      <a:prstDash val="solid"/>
-                      <a:round/>
-                      <a:headEnd type="none" w="med" len="med"/>
-                      <a:tailEnd type="none" w="med" len="med"/>
-                    </a:lnR>
-                    <a:lnT w="12700" cap="flat" cmpd="sng" algn="ctr">
-                      <a:solidFill>
-                        <a:srgbClr val="1E2761"/>
-                      </a:solidFill>
-                      <a:prstDash val="solid"/>
-                      <a:round/>
-                      <a:headEnd type="none" w="med" len="med"/>
-                      <a:tailEnd type="none" w="med" len="med"/>
-                    </a:lnT>
-                    <a:lnB w="12700" cap="flat" cmpd="sng" algn="ctr">
-                      <a:solidFill>
-                        <a:srgbClr val="1E2761"/>
-                      </a:solidFill>
-                      <a:prstDash val="solid"/>
-                      <a:round/>
-                      <a:headEnd type="none" w="med" len="med"/>
-                      <a:tailEnd type="none" w="med" len="med"/>
-                    </a:lnB>
-                    <a:solidFill>
-                      <a:srgbClr val="F5F5F5"/>
-                    </a:solidFill>
-                  </a:tcPr>
-                </a:tc>
-              </a:tr>
-            </a:tbl>
-          </a:graphicData>
-        </a:graphic>
-      </p:graphicFrame>
+      <p:pic>
+        <p:nvPicPr>
+          <p:cNvPr id="3" name="Image 0" descr="/Users/kelechiezekwe/Workspace/Computer_vision_lab/Project_work/outputs/figures/fig_height.png">    </p:cNvPr>
+          <p:cNvPicPr>
+            <a:picLocks noChangeAspect="1"/>
+          </p:cNvPicPr>
+          <p:nvPr/>
+        </p:nvPicPr>
+        <p:blipFill>
+          <a:blip r:embed="rId1"/>
+          <a:stretch>
+            <a:fillRect/>
+          </a:stretch>
+        </p:blipFill>
+        <p:spPr>
+          <a:xfrm>
+            <a:off x="914400" y="1097280"/>
+            <a:ext cx="7315200" cy="3200400"/>
+          </a:xfrm>
+          <a:prstGeom prst="rect">
+            <a:avLst/>
+          </a:prstGeom>
+        </p:spPr>
+      </p:pic>
+      <p:sp>
+        <p:nvSpPr>
+          <p:cNvPr id="4" name="Shape 1"/>
+          <p:cNvSpPr/>
+          <p:nvPr/>
+        </p:nvSpPr>
+        <p:spPr>
+          <a:xfrm>
+            <a:off x="1828800" y="4480560"/>
+            <a:ext cx="5486400" cy="548640"/>
+          </a:xfrm>
+          <a:prstGeom prst="rect">
+            <a:avLst/>
+          </a:prstGeom>
+          <a:solidFill>
+            <a:srgbClr val="2C5F2D"/>
+          </a:solidFill>
+          <a:ln/>
+        </p:spPr>
+      </p:sp>
       <p:sp>
         <p:nvSpPr>
           <p:cNvPr id="5" name="Text 2"/>
@@ -4037,8 +2928,8 @@
         </p:nvSpPr>
         <p:spPr>
           <a:xfrm>
-            <a:off x="731520" y="3108960"/>
-            <a:ext cx="7680960" cy="274320"/>
+            <a:off x="2011680" y="4572000"/>
+            <a:ext cx="5120640" cy="365760"/>
           </a:xfrm>
           <a:prstGeom prst="rect">
             <a:avLst/>
@@ -4050,118 +2941,18 @@
           <a:bodyPr wrap="square" rtlCol="0" anchor="ctr"/>
           <a:lstStyle/>
           <a:p>
-            <a:pPr indent="0" marL="0">
+            <a:pPr algn="ctr" indent="0" marL="0">
               <a:buNone/>
             </a:pPr>
             <a:r>
               <a:rPr lang="en-US" sz="1800" b="1" dirty="0">
                 <a:solidFill>
-                  <a:srgbClr val="028090"/>
-                </a:solidFill>
-              </a:rPr>
-              <a:t>System Progression:</a:t>
+                  <a:srgbClr val="FFFFFF"/>
+                </a:solidFill>
+              </a:rPr>
+              <a:t>Height: 0.49 ± 0.05m (consistent validation)</a:t>
             </a:r>
             <a:endParaRPr lang="en-US" sz="1800" dirty="0"/>
-          </a:p>
-        </p:txBody>
-      </p:sp>
-      <p:sp>
-        <p:nvSpPr>
-          <p:cNvPr id="6" name="Text 3"/>
-          <p:cNvSpPr txBox="1"/>
-          <p:nvPr/>
-        </p:nvSpPr>
-        <p:spPr>
-          <a:xfrm>
-            <a:off x="731520" y="3474720"/>
-            <a:ext cx="7680960" cy="822960"/>
-          </a:xfrm>
-          <a:prstGeom prst="rect">
-            <a:avLst/>
-          </a:prstGeom>
-          <a:noFill/>
-          <a:ln/>
-        </p:spPr>
-        <p:txBody>
-          <a:bodyPr wrap="square" rtlCol="0" anchor="ctr"/>
-          <a:lstStyle/>
-          <a:p>
-            <a:pPr algn="ctr" indent="0" marL="0">
-              <a:buNone/>
-            </a:pPr>
-            <a:r>
-              <a:rPr lang="en-US" sz="1500" dirty="0">
-                <a:solidFill>
-                  <a:srgbClr val="2C2C2C"/>
-                </a:solidFill>
-              </a:rPr>
-              <a:t>Stage 1: TPR=100%, FPR=60%</a:t>
-            </a:r>
-            <a:endParaRPr lang="en-US" sz="1500" dirty="0"/>
-          </a:p>
-          <a:p>
-            <a:pPr algn="ctr" indent="0" marL="0">
-              <a:buNone/>
-            </a:pPr>
-            <a:r>
-              <a:rPr lang="en-US" sz="1500" dirty="0">
-                <a:solidFill>
-                  <a:srgbClr val="2C2C2C"/>
-                </a:solidFill>
-              </a:rPr>
-              <a:t>Stage 2: TPR=96%, FPR=0%</a:t>
-            </a:r>
-            <a:endParaRPr lang="en-US" sz="1500" dirty="0"/>
-          </a:p>
-          <a:p>
-            <a:pPr algn="ctr" indent="0" marL="0">
-              <a:buNone/>
-            </a:pPr>
-            <a:r>
-              <a:rPr lang="en-US" sz="1500" dirty="0">
-                <a:solidFill>
-                  <a:srgbClr val="2C2C2C"/>
-                </a:solidFill>
-              </a:rPr>
-              <a:t>Stage 3: TPR=100%, FPR=0%</a:t>
-            </a:r>
-            <a:endParaRPr lang="en-US" sz="1500" dirty="0"/>
-          </a:p>
-        </p:txBody>
-      </p:sp>
-      <p:sp>
-        <p:nvSpPr>
-          <p:cNvPr id="7" name="Text 4"/>
-          <p:cNvSpPr txBox="1"/>
-          <p:nvPr/>
-        </p:nvSpPr>
-        <p:spPr>
-          <a:xfrm>
-            <a:off x="731520" y="4480560"/>
-            <a:ext cx="7680960" cy="274320"/>
-          </a:xfrm>
-          <a:prstGeom prst="rect">
-            <a:avLst/>
-          </a:prstGeom>
-          <a:noFill/>
-          <a:ln/>
-        </p:spPr>
-        <p:txBody>
-          <a:bodyPr wrap="square" rtlCol="0" anchor="ctr"/>
-          <a:lstStyle/>
-          <a:p>
-            <a:pPr algn="ctr" indent="0" marL="0">
-              <a:buNone/>
-            </a:pPr>
-            <a:r>
-              <a:rPr lang="en-US" sz="1600" b="1" dirty="0">
-                <a:solidFill>
-                  <a:srgbClr val="F96167"/>
-                </a:solidFill>
-              </a:rPr>
-              <a:t>Both targets significantly exceeded! ✓</a:t>
-            </a:r>
-            <a:endParaRPr lang="en-US" sz="1600" dirty="0"/>
           </a:p>
         </p:txBody>
       </p:sp>
@@ -4227,289 +3018,36 @@
                   <a:srgbClr val="1E2761"/>
                 </a:solidFill>
               </a:rPr>
-              <a:t>What We Achieved</a:t>
+              <a:t>Final System Performance</a:t>
             </a:r>
             <a:endParaRPr lang="en-US" sz="3600" dirty="0"/>
           </a:p>
         </p:txBody>
       </p:sp>
-      <p:sp>
-        <p:nvSpPr>
-          <p:cNvPr id="3" name="Text 1"/>
-          <p:cNvSpPr txBox="1"/>
-          <p:nvPr/>
-        </p:nvSpPr>
-        <p:spPr>
-          <a:xfrm>
-            <a:off x="731520" y="1097280"/>
-            <a:ext cx="7680960" cy="274320"/>
-          </a:xfrm>
-          <a:prstGeom prst="rect">
-            <a:avLst/>
-          </a:prstGeom>
-          <a:noFill/>
-          <a:ln/>
-        </p:spPr>
-        <p:txBody>
-          <a:bodyPr wrap="square" rtlCol="0" anchor="ctr"/>
-          <a:lstStyle/>
-          <a:p>
-            <a:pPr indent="0" marL="0">
-              <a:buNone/>
-            </a:pPr>
-            <a:r>
-              <a:rPr lang="en-US" sz="1800" b="1" dirty="0">
-                <a:solidFill>
-                  <a:srgbClr val="028090"/>
-                </a:solidFill>
-              </a:rPr>
-              <a:t>Technical Innovations:</a:t>
-            </a:r>
-            <a:endParaRPr lang="en-US" sz="1800" dirty="0"/>
-          </a:p>
-        </p:txBody>
-      </p:sp>
-      <p:sp>
-        <p:nvSpPr>
-          <p:cNvPr id="4" name="Text 2"/>
-          <p:cNvSpPr txBox="1"/>
-          <p:nvPr/>
-        </p:nvSpPr>
-        <p:spPr>
-          <a:xfrm>
-            <a:off x="731520" y="1463040"/>
-            <a:ext cx="7680960" cy="1097280"/>
-          </a:xfrm>
-          <a:prstGeom prst="rect">
-            <a:avLst/>
-          </a:prstGeom>
-          <a:noFill/>
-          <a:ln/>
-        </p:spPr>
-        <p:txBody>
-          <a:bodyPr wrap="square" rtlCol="0" anchor="ctr"/>
-          <a:lstStyle/>
-          <a:p>
-            <a:pPr marL="342900" indent="-342900">
-              <a:buSzPct val="100000"/>
-              <a:buChar char="•"/>
-            </a:pPr>
-            <a:r>
-              <a:rPr lang="en-US" sz="1400" dirty="0">
-                <a:solidFill>
-                  <a:srgbClr val="2C2C2C"/>
-                </a:solidFill>
-              </a:rPr>
-              <a:t>✓ Modular architecture enabling perfect performance</a:t>
-            </a:r>
-            <a:endParaRPr lang="en-US" sz="1400" dirty="0"/>
-          </a:p>
-          <a:p>
-            <a:pPr marL="342900" indent="-342900">
-              <a:buSzPct val="100000"/>
-              <a:buChar char="•"/>
-            </a:pPr>
-            <a:r>
-              <a:rPr lang="en-US" sz="1400" dirty="0">
-                <a:solidFill>
-                  <a:srgbClr val="2C2C2C"/>
-                </a:solidFill>
-              </a:rPr>
-              <a:t>✓ Intentional high-sensitivity baseline design</a:t>
-            </a:r>
-            <a:endParaRPr lang="en-US" sz="1400" dirty="0"/>
-          </a:p>
-          <a:p>
-            <a:pPr marL="342900" indent="-342900">
-              <a:buSzPct val="100000"/>
-              <a:buChar char="•"/>
-            </a:pPr>
-            <a:r>
-              <a:rPr lang="en-US" sz="1400" dirty="0">
-                <a:solidFill>
-                  <a:srgbClr val="2C2C2C"/>
-                </a:solidFill>
-              </a:rPr>
-              <a:t>✓ Simple depth cues achieving 0% FPR</a:t>
-            </a:r>
-            <a:endParaRPr lang="en-US" sz="1400" dirty="0"/>
-          </a:p>
-          <a:p>
-            <a:pPr marL="342900" indent="-342900">
-              <a:buSzPct val="100000"/>
-              <a:buChar char="•"/>
-            </a:pPr>
-            <a:r>
-              <a:rPr lang="en-US" sz="1400" dirty="0">
-                <a:solidFill>
-                  <a:srgbClr val="2C2C2C"/>
-                </a:solidFill>
-              </a:rPr>
-              <a:t>✓ Conservative tracking for edge case recovery</a:t>
-            </a:r>
-            <a:endParaRPr lang="en-US" sz="1400" dirty="0"/>
-          </a:p>
-        </p:txBody>
-      </p:sp>
-      <p:sp>
-        <p:nvSpPr>
-          <p:cNvPr id="5" name="Text 3"/>
-          <p:cNvSpPr txBox="1"/>
-          <p:nvPr/>
-        </p:nvSpPr>
-        <p:spPr>
-          <a:xfrm>
-            <a:off x="731520" y="2743200"/>
-            <a:ext cx="7680960" cy="274320"/>
-          </a:xfrm>
-          <a:prstGeom prst="rect">
-            <a:avLst/>
-          </a:prstGeom>
-          <a:noFill/>
-          <a:ln/>
-        </p:spPr>
-        <p:txBody>
-          <a:bodyPr wrap="square" rtlCol="0" anchor="ctr"/>
-          <a:lstStyle/>
-          <a:p>
-            <a:pPr indent="0" marL="0">
-              <a:buNone/>
-            </a:pPr>
-            <a:r>
-              <a:rPr lang="en-US" sz="1800" b="1" dirty="0">
-                <a:solidFill>
-                  <a:srgbClr val="028090"/>
-                </a:solidFill>
-              </a:rPr>
-              <a:t>Team Contributions:</a:t>
-            </a:r>
-            <a:endParaRPr lang="en-US" sz="1800" dirty="0"/>
-          </a:p>
-        </p:txBody>
-      </p:sp>
-      <p:sp>
-        <p:nvSpPr>
-          <p:cNvPr id="6" name="Text 4"/>
-          <p:cNvSpPr txBox="1"/>
-          <p:nvPr/>
-        </p:nvSpPr>
-        <p:spPr>
-          <a:xfrm>
-            <a:off x="731520" y="3108960"/>
-            <a:ext cx="7680960" cy="822960"/>
-          </a:xfrm>
-          <a:prstGeom prst="rect">
-            <a:avLst/>
-          </a:prstGeom>
-          <a:noFill/>
-          <a:ln/>
-        </p:spPr>
-        <p:txBody>
-          <a:bodyPr wrap="square" rtlCol="0" anchor="ctr"/>
-          <a:lstStyle/>
-          <a:p>
-            <a:pPr marL="342900" indent="-342900">
-              <a:buSzPct val="100000"/>
-              <a:buChar char="•"/>
-            </a:pPr>
-            <a:r>
-              <a:rPr lang="en-US" sz="1400" dirty="0">
-                <a:solidFill>
-                  <a:srgbClr val="2C2C2C"/>
-                </a:solidFill>
-              </a:rPr>
-              <a:t>• Kelechi: Perfect detection baseline (100% TPR)</a:t>
-            </a:r>
-            <a:endParaRPr lang="en-US" sz="1400" dirty="0"/>
-          </a:p>
-          <a:p>
-            <a:pPr marL="342900" indent="-342900">
-              <a:buSzPct val="100000"/>
-              <a:buChar char="•"/>
-            </a:pPr>
-            <a:r>
-              <a:rPr lang="en-US" sz="1400" dirty="0">
-                <a:solidFill>
-                  <a:srgbClr val="2C2C2C"/>
-                </a:solidFill>
-              </a:rPr>
-              <a:t>• Shravani: Perfect decoy rejection (0% FPR)</a:t>
-            </a:r>
-            <a:endParaRPr lang="en-US" sz="1400" dirty="0"/>
-          </a:p>
-          <a:p>
-            <a:pPr marL="342900" indent="-342900">
-              <a:buSzPct val="100000"/>
-              <a:buChar char="•"/>
-            </a:pPr>
-            <a:r>
-              <a:rPr lang="en-US" sz="1400" dirty="0">
-                <a:solidFill>
-                  <a:srgbClr val="2C2C2C"/>
-                </a:solidFill>
-              </a:rPr>
-              <a:t>• Thanigaiarasu: Accurate 3D + tracking (100% final TPR)</a:t>
-            </a:r>
-            <a:endParaRPr lang="en-US" sz="1400" dirty="0"/>
-          </a:p>
-        </p:txBody>
-      </p:sp>
-      <p:sp>
-        <p:nvSpPr>
-          <p:cNvPr id="7" name="Shape 5"/>
-          <p:cNvSpPr/>
-          <p:nvPr/>
-        </p:nvSpPr>
-        <p:spPr>
-          <a:xfrm>
-            <a:off x="2286000" y="4206240"/>
-            <a:ext cx="4572000" cy="548640"/>
-          </a:xfrm>
-          <a:prstGeom prst="rect">
-            <a:avLst/>
-          </a:prstGeom>
-          <a:solidFill>
-            <a:srgbClr val="028090"/>
-          </a:solidFill>
-          <a:ln/>
-        </p:spPr>
-      </p:sp>
-      <p:sp>
-        <p:nvSpPr>
-          <p:cNvPr id="8" name="Text 6"/>
-          <p:cNvSpPr txBox="1"/>
-          <p:nvPr/>
-        </p:nvSpPr>
-        <p:spPr>
-          <a:xfrm>
-            <a:off x="2468880" y="4297680"/>
-            <a:ext cx="4206240" cy="365760"/>
-          </a:xfrm>
-          <a:prstGeom prst="rect">
-            <a:avLst/>
-          </a:prstGeom>
-          <a:noFill/>
-          <a:ln/>
-        </p:spPr>
-        <p:txBody>
-          <a:bodyPr wrap="square" rtlCol="0" anchor="ctr"/>
-          <a:lstStyle/>
-          <a:p>
-            <a:pPr algn="ctr" indent="0" marL="0">
-              <a:buNone/>
-            </a:pPr>
-            <a:r>
-              <a:rPr lang="en-US" sz="1800" b="1" dirty="0">
-                <a:solidFill>
-                  <a:srgbClr val="FFFFFF"/>
-                </a:solidFill>
-              </a:rPr>
-              <a:t>Real-time: 15.2 ms/frame (66 FPS)</a:t>
-            </a:r>
-            <a:endParaRPr lang="en-US" sz="1800" dirty="0"/>
-          </a:p>
-        </p:txBody>
-      </p:sp>
+      <p:pic>
+        <p:nvPicPr>
+          <p:cNvPr id="3" name="Image 0" descr="/Users/kelechiezekwe/Workspace/Computer_vision_lab/Project_work/outputs/visualizations/6_summary_dashboard.png">    </p:cNvPr>
+          <p:cNvPicPr>
+            <a:picLocks noChangeAspect="1"/>
+          </p:cNvPicPr>
+          <p:nvPr/>
+        </p:nvPicPr>
+        <p:blipFill>
+          <a:blip r:embed="rId1"/>
+          <a:stretch>
+            <a:fillRect/>
+          </a:stretch>
+        </p:blipFill>
+        <p:spPr>
+          <a:xfrm>
+            <a:off x="457200" y="1005840"/>
+            <a:ext cx="8229600" cy="3931920"/>
+          </a:xfrm>
+          <a:prstGeom prst="rect">
+            <a:avLst/>
+          </a:prstGeom>
+        </p:spPr>
+      </p:pic>
     </p:spTree>
   </p:cSld>
   <p:clrMapOvr>
@@ -4660,7 +3198,7 @@
                   <a:srgbClr val="FFFFFF"/>
                 </a:solidFill>
               </a:rPr>
-              <a:t>✓ Real-time capable: 66 FPS on commodity hardware</a:t>
+              <a:t>✓ Real-time capable: 66 FPS</a:t>
             </a:r>
             <a:endParaRPr lang="en-US" sz="1300" dirty="0"/>
           </a:p>
@@ -4675,7 +3213,7 @@
                   <a:srgbClr val="FFFFFF"/>
                 </a:solidFill>
               </a:rPr>
-              <a:t>✓ Accurate 3D: 0.49 ± 0.05m validated</a:t>
+              <a:t>✓ Accurate 3D: 0.49 ± 0.05m</a:t>
             </a:r>
             <a:endParaRPr lang="en-US" sz="1300" dirty="0"/>
           </a:p>
@@ -4690,7 +3228,7 @@
                   <a:srgbClr val="FFFFFF"/>
                 </a:solidFill>
               </a:rPr>
-              <a:t>✓ Interpretable: Can explain every decision</a:t>
+              <a:t>✓ Interpretable: Explainable decisions</a:t>
             </a:r>
             <a:endParaRPr lang="en-US" sz="1300" dirty="0"/>
           </a:p>
@@ -4763,7 +3301,7 @@
                   <a:srgbClr val="FFFFFF"/>
                 </a:solidFill>
               </a:rPr>
-              <a:t>• Modular design enables effective debugging</a:t>
+              <a:t>• Modular design enables debugging</a:t>
             </a:r>
             <a:endParaRPr lang="en-US" sz="1300" dirty="0"/>
           </a:p>
@@ -4778,7 +3316,7 @@
                   <a:srgbClr val="FFFFFF"/>
                 </a:solidFill>
               </a:rPr>
-              <a:t>• Simple methods work when physics is clear</a:t>
+              <a:t>• Simple methods work with clear physics</a:t>
             </a:r>
             <a:endParaRPr lang="en-US" sz="1300" dirty="0"/>
           </a:p>
@@ -4793,7 +3331,7 @@
                   <a:srgbClr val="FFFFFF"/>
                 </a:solidFill>
               </a:rPr>
-              <a:t>• High baseline sensitivity provides robustness</a:t>
+              <a:t>• High baseline sensitivity = robustness</a:t>
             </a:r>
             <a:endParaRPr lang="en-US" sz="1300" dirty="0"/>
           </a:p>
@@ -4808,7 +3346,7 @@
                   <a:srgbClr val="FFFFFF"/>
                 </a:solidFill>
               </a:rPr>
-              <a:t>• Conservative extensions add value safely</a:t>
+              <a:t>• Conservative extensions add value</a:t>
             </a:r>
             <a:endParaRPr lang="en-US" sz="1300" dirty="0"/>
           </a:p>
@@ -5971,7 +4509,7 @@
                   <a:srgbClr val="1E2761"/>
                 </a:solidFill>
               </a:rPr>
-              <a:t>Stage 1: Fire Extinguisher Detection</a:t>
+              <a:t>Stage 1: Perfect Detection Performance</a:t>
             </a:r>
             <a:endParaRPr lang="en-US" sz="3600" dirty="0"/>
           </a:p>
@@ -6013,16 +4551,40 @@
           </a:p>
         </p:txBody>
       </p:sp>
-      <p:sp>
-        <p:nvSpPr>
-          <p:cNvPr id="4" name="Text 2"/>
+      <p:pic>
+        <p:nvPicPr>
+          <p:cNvPr id="4" name="Image 0" descr="/Users/kelechiezekwe/Workspace/Computer_vision_lab/Project_work/outputs/visualizations/1_tpr_fpr_comparison.png">    </p:cNvPr>
+          <p:cNvPicPr>
+            <a:picLocks noChangeAspect="1"/>
+          </p:cNvPicPr>
+          <p:nvPr/>
+        </p:nvPicPr>
+        <p:blipFill>
+          <a:blip r:embed="rId1"/>
+          <a:stretch>
+            <a:fillRect/>
+          </a:stretch>
+        </p:blipFill>
+        <p:spPr>
+          <a:xfrm>
+            <a:off x="1371600" y="1371600"/>
+            <a:ext cx="6400800" cy="3200400"/>
+          </a:xfrm>
+          <a:prstGeom prst="rect">
+            <a:avLst/>
+          </a:prstGeom>
+        </p:spPr>
+      </p:pic>
+      <p:sp>
+        <p:nvSpPr>
+          <p:cNvPr id="5" name="Text 2"/>
           <p:cNvSpPr txBox="1"/>
           <p:nvPr/>
         </p:nvSpPr>
         <p:spPr>
           <a:xfrm>
-            <a:off x="731520" y="1371600"/>
-            <a:ext cx="7680960" cy="1097280"/>
+            <a:off x="731520" y="4663440"/>
+            <a:ext cx="7680960" cy="274320"/>
           </a:xfrm>
           <a:prstGeom prst="rect">
             <a:avLst/>
@@ -6034,206 +4596,18 @@
           <a:bodyPr wrap="square" rtlCol="0" anchor="ctr"/>
           <a:lstStyle/>
           <a:p>
-            <a:pPr marL="342900" indent="-342900">
-              <a:buSzPct val="100000"/>
-              <a:buChar char="•"/>
-            </a:pPr>
-            <a:r>
-              <a:rPr lang="en-US" sz="1600" dirty="0">
-                <a:solidFill>
-                  <a:srgbClr val="2C2C2C"/>
-                </a:solidFill>
-              </a:rPr>
-              <a:t>• Model: YOLOv11n (nano variant)</a:t>
+            <a:pPr algn="ctr" indent="0" marL="0">
+              <a:buNone/>
+            </a:pPr>
+            <a:r>
+              <a:rPr lang="en-US" sz="1600" b="1" dirty="0">
+                <a:solidFill>
+                  <a:srgbClr val="2C5F2D"/>
+                </a:solidFill>
+              </a:rPr>
+              <a:t>100% TPR on both eval and test sets - Zero misses!</a:t>
             </a:r>
             <a:endParaRPr lang="en-US" sz="1600" dirty="0"/>
-          </a:p>
-          <a:p>
-            <a:pPr marL="342900" indent="-342900">
-              <a:buSzPct val="100000"/>
-              <a:buChar char="•"/>
-            </a:pPr>
-            <a:r>
-              <a:rPr lang="en-US" sz="1600" dirty="0">
-                <a:solidFill>
-                  <a:srgbClr val="2C2C2C"/>
-                </a:solidFill>
-              </a:rPr>
-              <a:t>• Training: Roboflow FireExtinguisher v2 (~500 images)</a:t>
-            </a:r>
-            <a:endParaRPr lang="en-US" sz="1600" dirty="0"/>
-          </a:p>
-          <a:p>
-            <a:pPr marL="342900" indent="-342900">
-              <a:buSzPct val="100000"/>
-              <a:buChar char="•"/>
-            </a:pPr>
-            <a:r>
-              <a:rPr lang="en-US" sz="1600" dirty="0">
-                <a:solidFill>
-                  <a:srgbClr val="2C2C2C"/>
-                </a:solidFill>
-              </a:rPr>
-              <a:t>• Confidence threshold: 0.10 (intentionally low)</a:t>
-            </a:r>
-            <a:endParaRPr lang="en-US" sz="1600" dirty="0"/>
-          </a:p>
-          <a:p>
-            <a:pPr marL="342900" indent="-342900">
-              <a:buSzPct val="100000"/>
-              <a:buChar char="•"/>
-            </a:pPr>
-            <a:r>
-              <a:rPr lang="en-US" sz="1600" dirty="0">
-                <a:solidFill>
-                  <a:srgbClr val="2C2C2C"/>
-                </a:solidFill>
-              </a:rPr>
-              <a:t>• Platform: Google Colab (T4 GPU)</a:t>
-            </a:r>
-            <a:endParaRPr lang="en-US" sz="1600" dirty="0"/>
-          </a:p>
-        </p:txBody>
-      </p:sp>
-      <p:sp>
-        <p:nvSpPr>
-          <p:cNvPr id="5" name="Shape 3"/>
-          <p:cNvSpPr/>
-          <p:nvPr/>
-        </p:nvSpPr>
-        <p:spPr>
-          <a:xfrm>
-            <a:off x="1371600" y="2926080"/>
-            <a:ext cx="6400800" cy="731520"/>
-          </a:xfrm>
-          <a:prstGeom prst="rect">
-            <a:avLst/>
-          </a:prstGeom>
-          <a:solidFill>
-            <a:srgbClr val="F96167"/>
-          </a:solidFill>
-          <a:ln/>
-        </p:spPr>
-      </p:sp>
-      <p:sp>
-        <p:nvSpPr>
-          <p:cNvPr id="6" name="Text 4"/>
-          <p:cNvSpPr txBox="1"/>
-          <p:nvPr/>
-        </p:nvSpPr>
-        <p:spPr>
-          <a:xfrm>
-            <a:off x="1554480" y="3017520"/>
-            <a:ext cx="6035040" cy="274320"/>
-          </a:xfrm>
-          <a:prstGeom prst="rect">
-            <a:avLst/>
-          </a:prstGeom>
-          <a:noFill/>
-          <a:ln/>
-        </p:spPr>
-        <p:txBody>
-          <a:bodyPr wrap="square" rtlCol="0" anchor="ctr"/>
-          <a:lstStyle/>
-          <a:p>
-            <a:pPr indent="0" marL="0">
-              <a:buNone/>
-            </a:pPr>
-            <a:r>
-              <a:rPr lang="en-US" sz="1800" b="1" dirty="0">
-                <a:solidFill>
-                  <a:srgbClr val="FFFFFF"/>
-                </a:solidFill>
-              </a:rPr>
-              <a:t>Key Achievement:</a:t>
-            </a:r>
-            <a:endParaRPr lang="en-US" sz="1800" dirty="0"/>
-          </a:p>
-        </p:txBody>
-      </p:sp>
-      <p:sp>
-        <p:nvSpPr>
-          <p:cNvPr id="7" name="Text 5"/>
-          <p:cNvSpPr txBox="1"/>
-          <p:nvPr/>
-        </p:nvSpPr>
-        <p:spPr>
-          <a:xfrm>
-            <a:off x="1554480" y="3337560"/>
-            <a:ext cx="6035040" cy="274320"/>
-          </a:xfrm>
-          <a:prstGeom prst="rect">
-            <a:avLst/>
-          </a:prstGeom>
-          <a:noFill/>
-          <a:ln/>
-        </p:spPr>
-        <p:txBody>
-          <a:bodyPr wrap="square" rtlCol="0" anchor="ctr"/>
-          <a:lstStyle/>
-          <a:p>
-            <a:pPr indent="0" marL="0">
-              <a:buNone/>
-            </a:pPr>
-            <a:r>
-              <a:rPr lang="en-US" sz="2000" b="1" dirty="0">
-                <a:solidFill>
-                  <a:srgbClr val="FFFFFF"/>
-                </a:solidFill>
-              </a:rPr>
-              <a:t>100% TPR on both eval and test sets</a:t>
-            </a:r>
-            <a:endParaRPr lang="en-US" sz="2000" dirty="0"/>
-          </a:p>
-        </p:txBody>
-      </p:sp>
-      <p:sp>
-        <p:nvSpPr>
-          <p:cNvPr id="8" name="Text 6"/>
-          <p:cNvSpPr txBox="1"/>
-          <p:nvPr/>
-        </p:nvSpPr>
-        <p:spPr>
-          <a:xfrm>
-            <a:off x="731520" y="3931920"/>
-            <a:ext cx="7680960" cy="548640"/>
-          </a:xfrm>
-          <a:prstGeom prst="rect">
-            <a:avLst/>
-          </a:prstGeom>
-          <a:noFill/>
-          <a:ln/>
-        </p:spPr>
-        <p:txBody>
-          <a:bodyPr wrap="square" rtlCol="0" anchor="ctr"/>
-          <a:lstStyle/>
-          <a:p>
-            <a:pPr algn="ctr" indent="0" marL="0">
-              <a:buNone/>
-            </a:pPr>
-            <a:r>
-              <a:rPr lang="en-US" sz="1400" dirty="0">
-                <a:solidFill>
-                  <a:srgbClr val="2C2C2C"/>
-                </a:solidFill>
-              </a:rPr>
-              <a:t>Perfect detection of all real fire extinguishers</a:t>
-            </a:r>
-            <a:endParaRPr lang="en-US" sz="1400" dirty="0"/>
-          </a:p>
-          <a:p>
-            <a:pPr algn="ctr" indent="0" marL="0">
-              <a:buNone/>
-            </a:pPr>
-            <a:r>
-              <a:rPr lang="en-US" sz="1400" dirty="0">
-                <a:solidFill>
-                  <a:srgbClr val="2C2C2C"/>
-                </a:solidFill>
-              </a:rPr>
-              <a:t>Zero misses - safety-critical requirement met</a:t>
-            </a:r>
-            <a:endParaRPr lang="en-US" sz="1400" dirty="0"/>
           </a:p>
         </p:txBody>
       </p:sp>
@@ -6294,26 +4668,50 @@
               <a:buNone/>
             </a:pPr>
             <a:r>
-              <a:rPr lang="en-US" sz="3200" b="1" dirty="0">
+              <a:rPr lang="en-US" sz="3600" b="1" dirty="0">
                 <a:solidFill>
                   <a:srgbClr val="1E2761"/>
                 </a:solidFill>
               </a:rPr>
-              <a:t>Design Choice: Intentional High False Positive Rate</a:t>
-            </a:r>
-            <a:endParaRPr lang="en-US" sz="3200" dirty="0"/>
-          </a:p>
-        </p:txBody>
-      </p:sp>
-      <p:sp>
-        <p:nvSpPr>
-          <p:cNvPr id="3" name="Text 1"/>
+              <a:t>Stage 1: Detection Breakdown Analysis</a:t>
+            </a:r>
+            <a:endParaRPr lang="en-US" sz="3600" dirty="0"/>
+          </a:p>
+        </p:txBody>
+      </p:sp>
+      <p:pic>
+        <p:nvPicPr>
+          <p:cNvPr id="3" name="Image 0" descr="/Users/kelechiezekwe/Workspace/Computer_vision_lab/Project_work/outputs/visualizations/2_detection_breakdown.png">    </p:cNvPr>
+          <p:cNvPicPr>
+            <a:picLocks noChangeAspect="1"/>
+          </p:cNvPicPr>
+          <p:nvPr/>
+        </p:nvPicPr>
+        <p:blipFill>
+          <a:blip r:embed="rId1"/>
+          <a:stretch>
+            <a:fillRect/>
+          </a:stretch>
+        </p:blipFill>
+        <p:spPr>
+          <a:xfrm>
+            <a:off x="731520" y="1097280"/>
+            <a:ext cx="7680960" cy="3474720"/>
+          </a:xfrm>
+          <a:prstGeom prst="rect">
+            <a:avLst/>
+          </a:prstGeom>
+        </p:spPr>
+      </p:pic>
+      <p:sp>
+        <p:nvSpPr>
+          <p:cNvPr id="4" name="Text 1"/>
           <p:cNvSpPr txBox="1"/>
           <p:nvPr/>
         </p:nvSpPr>
         <p:spPr>
           <a:xfrm>
-            <a:off x="731520" y="1097280"/>
+            <a:off x="731520" y="4663440"/>
             <a:ext cx="7680960" cy="274320"/>
           </a:xfrm>
           <a:prstGeom prst="rect">
@@ -6326,258 +4724,18 @@
           <a:bodyPr wrap="square" rtlCol="0" anchor="ctr"/>
           <a:lstStyle/>
           <a:p>
-            <a:pPr indent="0" marL="0">
-              <a:buNone/>
-            </a:pPr>
-            <a:r>
-              <a:rPr lang="en-US" sz="1800" b="1" dirty="0">
-                <a:solidFill>
-                  <a:srgbClr val="028090"/>
-                </a:solidFill>
-              </a:rPr>
-              <a:t>The Argument:</a:t>
-            </a:r>
-            <a:endParaRPr lang="en-US" sz="1800" dirty="0"/>
-          </a:p>
-        </p:txBody>
-      </p:sp>
-      <p:sp>
-        <p:nvSpPr>
-          <p:cNvPr id="4" name="Text 2"/>
-          <p:cNvSpPr txBox="1"/>
-          <p:nvPr/>
-        </p:nvSpPr>
-        <p:spPr>
-          <a:xfrm>
-            <a:off x="731520" y="1463040"/>
-            <a:ext cx="7680960" cy="822960"/>
-          </a:xfrm>
-          <a:prstGeom prst="rect">
-            <a:avLst/>
-          </a:prstGeom>
-          <a:noFill/>
-          <a:ln/>
-        </p:spPr>
-        <p:txBody>
-          <a:bodyPr wrap="square" rtlCol="0" anchor="ctr"/>
-          <a:lstStyle/>
-          <a:p>
-            <a:pPr marL="342900" indent="-342900">
-              <a:buSzPct val="100000"/>
-              <a:buChar char="•"/>
-            </a:pPr>
-            <a:r>
-              <a:rPr lang="en-US" sz="1500" dirty="0">
+            <a:pPr algn="ctr" indent="0" marL="0">
+              <a:buNone/>
+            </a:pPr>
+            <a:r>
+              <a:rPr lang="en-US" sz="1400" i="1" dirty="0">
                 <a:solidFill>
                   <a:srgbClr val="2C2C2C"/>
                 </a:solidFill>
               </a:rPr>
-              <a:t>• Stage 1: High sensitivity (TPR=100%, FPR=60%)</a:t>
-            </a:r>
-            <a:endParaRPr lang="en-US" sz="1500" dirty="0"/>
-          </a:p>
-          <a:p>
-            <a:pPr marL="342900" indent="-342900">
-              <a:buSzPct val="100000"/>
-              <a:buChar char="•"/>
-            </a:pPr>
-            <a:r>
-              <a:rPr lang="en-US" sz="1500" dirty="0">
-                <a:solidFill>
-                  <a:srgbClr val="2C2C2C"/>
-                </a:solidFill>
-              </a:rPr>
-              <a:t>• Stage 2: High specificity (filters false positives)</a:t>
-            </a:r>
-            <a:endParaRPr lang="en-US" sz="1500" dirty="0"/>
-          </a:p>
-          <a:p>
-            <a:pPr marL="342900" indent="-342900">
-              <a:buSzPct val="100000"/>
-              <a:buChar char="•"/>
-            </a:pPr>
-            <a:r>
-              <a:rPr lang="en-US" sz="1500" dirty="0">
-                <a:solidFill>
-                  <a:srgbClr val="2C2C2C"/>
-                </a:solidFill>
-              </a:rPr>
-              <a:t>• Result: Perfect final performance</a:t>
-            </a:r>
-            <a:endParaRPr lang="en-US" sz="1500" dirty="0"/>
-          </a:p>
-        </p:txBody>
-      </p:sp>
-      <p:sp>
-        <p:nvSpPr>
-          <p:cNvPr id="5" name="Text 3"/>
-          <p:cNvSpPr txBox="1"/>
-          <p:nvPr/>
-        </p:nvSpPr>
-        <p:spPr>
-          <a:xfrm>
-            <a:off x="731520" y="2468880"/>
-            <a:ext cx="7680960" cy="274320"/>
-          </a:xfrm>
-          <a:prstGeom prst="rect">
-            <a:avLst/>
-          </a:prstGeom>
-          <a:noFill/>
-          <a:ln/>
-        </p:spPr>
-        <p:txBody>
-          <a:bodyPr wrap="square" rtlCol="0" anchor="ctr"/>
-          <a:lstStyle/>
-          <a:p>
-            <a:pPr indent="0" marL="0">
-              <a:buNone/>
-            </a:pPr>
-            <a:r>
-              <a:rPr lang="en-US" sz="1800" b="1" dirty="0">
-                <a:solidFill>
-                  <a:srgbClr val="028090"/>
-                </a:solidFill>
-              </a:rPr>
-              <a:t>Mathematical Justification:</a:t>
-            </a:r>
-            <a:endParaRPr lang="en-US" sz="1800" dirty="0"/>
-          </a:p>
-        </p:txBody>
-      </p:sp>
-      <p:sp>
-        <p:nvSpPr>
-          <p:cNvPr id="6" name="Text 4"/>
-          <p:cNvSpPr txBox="1"/>
-          <p:nvPr/>
-        </p:nvSpPr>
-        <p:spPr>
-          <a:xfrm>
-            <a:off x="731520" y="2834640"/>
-            <a:ext cx="7680960" cy="822960"/>
-          </a:xfrm>
-          <a:prstGeom prst="rect">
-            <a:avLst/>
-          </a:prstGeom>
-          <a:noFill/>
-          <a:ln/>
-        </p:spPr>
-        <p:txBody>
-          <a:bodyPr wrap="square" rtlCol="0" anchor="ctr"/>
-          <a:lstStyle/>
-          <a:p>
-            <a:pPr marL="342900" indent="-342900">
-              <a:buSzPct val="100000"/>
-              <a:buChar char="•"/>
-            </a:pPr>
-            <a:r>
-              <a:rPr lang="en-US" sz="1500" dirty="0">
-                <a:solidFill>
-                  <a:srgbClr val="2C2C2C"/>
-                </a:solidFill>
-              </a:rPr>
-              <a:t>• Final TPR = Stage1_TPR × Stage2_TPR</a:t>
-            </a:r>
-            <a:endParaRPr lang="en-US" sz="1500" dirty="0"/>
-          </a:p>
-          <a:p>
-            <a:pPr marL="342900" indent="-342900">
-              <a:buSzPct val="100000"/>
-              <a:buChar char="•"/>
-            </a:pPr>
-            <a:r>
-              <a:rPr lang="en-US" sz="1500" dirty="0">
-                <a:solidFill>
-                  <a:srgbClr val="2C2C2C"/>
-                </a:solidFill>
-              </a:rPr>
-              <a:t>• Our approach: 1.00 × 0.96 = 0.96 ✓</a:t>
-            </a:r>
-            <a:endParaRPr lang="en-US" sz="1500" dirty="0"/>
-          </a:p>
-          <a:p>
-            <a:pPr marL="342900" indent="-342900">
-              <a:buSzPct val="100000"/>
-              <a:buChar char="•"/>
-            </a:pPr>
-            <a:r>
-              <a:rPr lang="en-US" sz="1500" dirty="0">
-                <a:solidFill>
-                  <a:srgbClr val="2C2C2C"/>
-                </a:solidFill>
-              </a:rPr>
-              <a:t>• Alternative: 0.90 × 1.00 = 0.90 (no safety margin)</a:t>
-            </a:r>
-            <a:endParaRPr lang="en-US" sz="1500" dirty="0"/>
-          </a:p>
-        </p:txBody>
-      </p:sp>
-      <p:sp>
-        <p:nvSpPr>
-          <p:cNvPr id="7" name="Shape 5"/>
-          <p:cNvSpPr/>
-          <p:nvPr/>
-        </p:nvSpPr>
-        <p:spPr>
-          <a:xfrm>
-            <a:off x="914400" y="3931920"/>
-            <a:ext cx="7315200" cy="731520"/>
-          </a:xfrm>
-          <a:prstGeom prst="rect">
-            <a:avLst/>
-          </a:prstGeom>
-          <a:solidFill>
-            <a:srgbClr val="F5F5F5"/>
-          </a:solidFill>
-          <a:ln/>
-        </p:spPr>
-      </p:sp>
-      <p:sp>
-        <p:nvSpPr>
-          <p:cNvPr id="8" name="Text 6"/>
-          <p:cNvSpPr txBox="1"/>
-          <p:nvPr/>
-        </p:nvSpPr>
-        <p:spPr>
-          <a:xfrm>
-            <a:off x="914400" y="4023360"/>
-            <a:ext cx="7315200" cy="548640"/>
-          </a:xfrm>
-          <a:prstGeom prst="rect">
-            <a:avLst/>
-          </a:prstGeom>
-          <a:noFill/>
-          <a:ln/>
-        </p:spPr>
-        <p:txBody>
-          <a:bodyPr wrap="square" rtlCol="0" anchor="ctr"/>
-          <a:lstStyle/>
-          <a:p>
-            <a:pPr algn="ctr" indent="0" marL="0">
-              <a:buNone/>
-            </a:pPr>
-            <a:r>
-              <a:rPr lang="en-US" sz="1600" b="1" dirty="0">
-                <a:solidFill>
-                  <a:srgbClr val="F96167"/>
-                </a:solidFill>
-              </a:rPr>
-              <a:t>The 2 misses from Stage 2 would be unrecoverable</a:t>
-            </a:r>
-            <a:endParaRPr lang="en-US" sz="1600" dirty="0"/>
-          </a:p>
-          <a:p>
-            <a:pPr algn="ctr" indent="0" marL="0">
-              <a:buNone/>
-            </a:pPr>
-            <a:r>
-              <a:rPr lang="en-US" sz="1600" b="1" dirty="0">
-                <a:solidFill>
-                  <a:srgbClr val="F96167"/>
-                </a:solidFill>
-              </a:rPr>
-              <a:t>if Stage 1 missed them!</a:t>
-            </a:r>
-            <a:endParaRPr lang="en-US" sz="1600" dirty="0"/>
+              <a:t>Perfect recall on safety-critical real objects</a:t>
+            </a:r>
+            <a:endParaRPr lang="en-US" sz="1400" dirty="0"/>
           </a:p>
         </p:txBody>
       </p:sp>
@@ -6638,27 +4796,71 @@
               <a:buNone/>
             </a:pPr>
             <a:r>
-              <a:rPr lang="en-US" sz="3600" b="1" dirty="0">
+              <a:rPr lang="en-US" sz="3200" b="1" dirty="0">
                 <a:solidFill>
                   <a:srgbClr val="1E2761"/>
                 </a:solidFill>
               </a:rPr>
-              <a:t>Stage 1: Perfect Detection Performance</a:t>
-            </a:r>
-            <a:endParaRPr lang="en-US" sz="3600" dirty="0"/>
-          </a:p>
-        </p:txBody>
-      </p:sp>
-      <p:sp>
-        <p:nvSpPr>
-          <p:cNvPr id="3" name="Text 1"/>
+              <a:t>Design Choice: Intentional High False Positive Rate</a:t>
+            </a:r>
+            <a:endParaRPr lang="en-US" sz="3200" dirty="0"/>
+          </a:p>
+        </p:txBody>
+      </p:sp>
+      <p:pic>
+        <p:nvPicPr>
+          <p:cNvPr id="3" name="Image 0" descr="/Users/kelechiezekwe/Workspace/Computer_vision_lab/Project_work/outputs/visualizations/3_metrics_comparison.png">    </p:cNvPr>
+          <p:cNvPicPr>
+            <a:picLocks noChangeAspect="1"/>
+          </p:cNvPicPr>
+          <p:nvPr/>
+        </p:nvPicPr>
+        <p:blipFill>
+          <a:blip r:embed="rId1"/>
+          <a:stretch>
+            <a:fillRect/>
+          </a:stretch>
+        </p:blipFill>
+        <p:spPr>
+          <a:xfrm>
+            <a:off x="731520" y="1097280"/>
+            <a:ext cx="3657600" cy="3200400"/>
+          </a:xfrm>
+          <a:prstGeom prst="rect">
+            <a:avLst/>
+          </a:prstGeom>
+        </p:spPr>
+      </p:pic>
+      <p:sp>
+        <p:nvSpPr>
+          <p:cNvPr id="4" name="Shape 1"/>
+          <p:cNvSpPr/>
+          <p:nvPr/>
+        </p:nvSpPr>
+        <p:spPr>
+          <a:xfrm>
+            <a:off x="4754880" y="1097280"/>
+            <a:ext cx="3657600" cy="1645920"/>
+          </a:xfrm>
+          <a:prstGeom prst="rect">
+            <a:avLst/>
+          </a:prstGeom>
+          <a:solidFill>
+            <a:srgbClr val="F5F5F5"/>
+          </a:solidFill>
+          <a:ln/>
+        </p:spPr>
+      </p:sp>
+      <p:sp>
+        <p:nvSpPr>
+          <p:cNvPr id="5" name="Text 2"/>
           <p:cNvSpPr txBox="1"/>
           <p:nvPr/>
         </p:nvSpPr>
         <p:spPr>
           <a:xfrm>
-            <a:off x="731520" y="1097280"/>
-            <a:ext cx="7680960" cy="274320"/>
+            <a:off x="4937760" y="1188720"/>
+            <a:ext cx="3291840" cy="274320"/>
           </a:xfrm>
           <a:prstGeom prst="rect">
             <a:avLst/>
@@ -6674,27 +4876,27 @@
               <a:buNone/>
             </a:pPr>
             <a:r>
-              <a:rPr lang="en-US" sz="2000" b="1" dirty="0">
+              <a:rPr lang="en-US" sz="1600" b="1" dirty="0">
                 <a:solidFill>
                   <a:srgbClr val="028090"/>
                 </a:solidFill>
               </a:rPr>
-              <a:t>Test Set Results:</a:t>
-            </a:r>
-            <a:endParaRPr lang="en-US" sz="2000" dirty="0"/>
-          </a:p>
-        </p:txBody>
-      </p:sp>
-      <p:sp>
-        <p:nvSpPr>
-          <p:cNvPr id="4" name="Text 2"/>
+              <a:t>Mathematical Justification:</a:t>
+            </a:r>
+            <a:endParaRPr lang="en-US" sz="1600" dirty="0"/>
+          </a:p>
+        </p:txBody>
+      </p:sp>
+      <p:sp>
+        <p:nvSpPr>
+          <p:cNvPr id="6" name="Text 3"/>
           <p:cNvSpPr txBox="1"/>
           <p:nvPr/>
         </p:nvSpPr>
         <p:spPr>
           <a:xfrm>
-            <a:off x="731520" y="1463040"/>
-            <a:ext cx="3657600" cy="822960"/>
+            <a:off x="4937760" y="1554480"/>
+            <a:ext cx="3291840" cy="1097280"/>
           </a:xfrm>
           <a:prstGeom prst="rect">
             <a:avLst/>
@@ -6706,62 +4908,119 @@
           <a:bodyPr wrap="square" rtlCol="0" anchor="ctr"/>
           <a:lstStyle/>
           <a:p>
-            <a:pPr marL="342900" indent="-342900">
-              <a:buSzPct val="100000"/>
-              <a:buChar char="•"/>
-            </a:pPr>
-            <a:r>
-              <a:rPr lang="en-US" sz="1500" b="1" dirty="0">
-                <a:solidFill>
-                  <a:srgbClr val="2C5F2D"/>
-                </a:solidFill>
-              </a:rPr>
-              <a:t>• Real detected: 45/45 (100%)</a:t>
-            </a:r>
-            <a:endParaRPr lang="en-US" sz="1500" dirty="0"/>
-          </a:p>
-          <a:p>
-            <a:pPr marL="342900" indent="-342900">
-              <a:buSzPct val="100000"/>
-              <a:buChar char="•"/>
-            </a:pPr>
-            <a:r>
-              <a:rPr lang="en-US" sz="1500" b="1" dirty="0">
-                <a:solidFill>
-                  <a:srgbClr val="2C5F2D"/>
-                </a:solidFill>
-              </a:rPr>
-              <a:t>• Real missed: 0/45 (zero!)</a:t>
-            </a:r>
-            <a:endParaRPr lang="en-US" sz="1500" dirty="0"/>
-          </a:p>
-          <a:p>
-            <a:pPr marL="342900" indent="-342900">
-              <a:buSzPct val="100000"/>
-              <a:buChar char="•"/>
-            </a:pPr>
-            <a:r>
-              <a:rPr lang="en-US" sz="1500" b="1" dirty="0">
-                <a:solidFill>
-                  <a:srgbClr val="2C5F2D"/>
-                </a:solidFill>
-              </a:rPr>
-              <a:t>• TPR: 1.0000 ✓ (target ≥ 0.75)</a:t>
-            </a:r>
-            <a:endParaRPr lang="en-US" sz="1500" dirty="0"/>
-          </a:p>
-        </p:txBody>
-      </p:sp>
-      <p:sp>
-        <p:nvSpPr>
-          <p:cNvPr id="5" name="Text 3"/>
+            <a:pPr indent="0" marL="0">
+              <a:buNone/>
+            </a:pPr>
+            <a:r>
+              <a:rPr lang="en-US" sz="1300" dirty="0">
+                <a:solidFill>
+                  <a:srgbClr val="2C2C2C"/>
+                </a:solidFill>
+              </a:rPr>
+              <a:t>Final TPR = Stage1_TPR × Stage2_TPR</a:t>
+            </a:r>
+            <a:endParaRPr lang="en-US" sz="1300" dirty="0"/>
+          </a:p>
+          <a:p>
+            <a:pPr indent="0" marL="0">
+              <a:buNone/>
+            </a:pPr>
+            <a:endParaRPr lang="en-US" sz="1300" dirty="0"/>
+          </a:p>
+          <a:p>
+            <a:pPr indent="0" marL="0">
+              <a:buNone/>
+            </a:pPr>
+            <a:r>
+              <a:rPr lang="en-US" sz="1300" dirty="0">
+                <a:solidFill>
+                  <a:srgbClr val="2C2C2C"/>
+                </a:solidFill>
+              </a:rPr>
+              <a:t>Our approach:</a:t>
+            </a:r>
+            <a:endParaRPr lang="en-US" sz="1300" dirty="0"/>
+          </a:p>
+          <a:p>
+            <a:pPr indent="0" marL="0">
+              <a:buNone/>
+            </a:pPr>
+            <a:r>
+              <a:rPr lang="en-US" sz="1300" dirty="0">
+                <a:solidFill>
+                  <a:srgbClr val="2C2C2C"/>
+                </a:solidFill>
+              </a:rPr>
+              <a:t>1.00 × 0.96 = 0.96 ✓</a:t>
+            </a:r>
+            <a:endParaRPr lang="en-US" sz="1300" dirty="0"/>
+          </a:p>
+          <a:p>
+            <a:pPr indent="0" marL="0">
+              <a:buNone/>
+            </a:pPr>
+            <a:endParaRPr lang="en-US" sz="1300" dirty="0"/>
+          </a:p>
+          <a:p>
+            <a:pPr indent="0" marL="0">
+              <a:buNone/>
+            </a:pPr>
+            <a:r>
+              <a:rPr lang="en-US" sz="1300" dirty="0">
+                <a:solidFill>
+                  <a:srgbClr val="2C2C2C"/>
+                </a:solidFill>
+              </a:rPr>
+              <a:t>Alternative:</a:t>
+            </a:r>
+            <a:endParaRPr lang="en-US" sz="1300" dirty="0"/>
+          </a:p>
+          <a:p>
+            <a:pPr indent="0" marL="0">
+              <a:buNone/>
+            </a:pPr>
+            <a:r>
+              <a:rPr lang="en-US" sz="1300" dirty="0">
+                <a:solidFill>
+                  <a:srgbClr val="2C2C2C"/>
+                </a:solidFill>
+              </a:rPr>
+              <a:t>0.90 × 1.00 = 0.90 ✗</a:t>
+            </a:r>
+            <a:endParaRPr lang="en-US" sz="1300" dirty="0"/>
+          </a:p>
+        </p:txBody>
+      </p:sp>
+      <p:sp>
+        <p:nvSpPr>
+          <p:cNvPr id="7" name="Shape 4"/>
+          <p:cNvSpPr/>
+          <p:nvPr/>
+        </p:nvSpPr>
+        <p:spPr>
+          <a:xfrm>
+            <a:off x="4754880" y="2926080"/>
+            <a:ext cx="3657600" cy="731520"/>
+          </a:xfrm>
+          <a:prstGeom prst="rect">
+            <a:avLst/>
+          </a:prstGeom>
+          <a:solidFill>
+            <a:srgbClr val="F96167"/>
+          </a:solidFill>
+          <a:ln/>
+        </p:spPr>
+      </p:sp>
+      <p:sp>
+        <p:nvSpPr>
+          <p:cNvPr id="8" name="Text 5"/>
           <p:cNvSpPr txBox="1"/>
           <p:nvPr/>
         </p:nvSpPr>
         <p:spPr>
           <a:xfrm>
-            <a:off x="4754880" y="1463040"/>
-            <a:ext cx="3657600" cy="822960"/>
+            <a:off x="4846320" y="3017520"/>
+            <a:ext cx="3474720" cy="548640"/>
           </a:xfrm>
           <a:prstGeom prst="rect">
             <a:avLst/>
@@ -6773,177 +5032,32 @@
           <a:bodyPr wrap="square" rtlCol="0" anchor="ctr"/>
           <a:lstStyle/>
           <a:p>
-            <a:pPr marL="342900" indent="-342900">
-              <a:buSzPct val="100000"/>
-              <a:buChar char="•"/>
-            </a:pPr>
-            <a:r>
-              <a:rPr lang="en-US" sz="1500" dirty="0">
-                <a:solidFill>
-                  <a:srgbClr val="2C2C2C"/>
-                </a:solidFill>
-              </a:rPr>
-              <a:t>• Decoys detected: 62/103 (60%)</a:t>
-            </a:r>
-            <a:endParaRPr lang="en-US" sz="1500" dirty="0"/>
-          </a:p>
-          <a:p>
-            <a:pPr marL="342900" indent="-342900">
-              <a:buSzPct val="100000"/>
-              <a:buChar char="•"/>
-            </a:pPr>
-            <a:r>
-              <a:rPr lang="en-US" sz="1500" dirty="0">
-                <a:solidFill>
-                  <a:srgbClr val="2C2C2C"/>
-                </a:solidFill>
-              </a:rPr>
-              <a:t>• FPR: 0.6019</a:t>
-            </a:r>
-            <a:endParaRPr lang="en-US" sz="1500" dirty="0"/>
-          </a:p>
-          <a:p>
-            <a:pPr marL="342900" indent="-342900">
-              <a:buSzPct val="100000"/>
-              <a:buChar char="•"/>
-            </a:pPr>
-            <a:r>
-              <a:rPr lang="en-US" sz="1500" dirty="0">
-                <a:solidFill>
-                  <a:srgbClr val="2C2C2C"/>
-                </a:solidFill>
-              </a:rPr>
-              <a:t>  (expected, will be filtered)</a:t>
-            </a:r>
-            <a:endParaRPr lang="en-US" sz="1500" dirty="0"/>
-          </a:p>
-        </p:txBody>
-      </p:sp>
-      <p:sp>
-        <p:nvSpPr>
-          <p:cNvPr id="6" name="Shape 4"/>
-          <p:cNvSpPr/>
-          <p:nvPr/>
-        </p:nvSpPr>
-        <p:spPr>
-          <a:xfrm>
-            <a:off x="1371600" y="2743200"/>
-            <a:ext cx="6400800" cy="731520"/>
-          </a:xfrm>
-          <a:prstGeom prst="rect">
-            <a:avLst/>
-          </a:prstGeom>
-          <a:solidFill>
-            <a:srgbClr val="2C5F2D"/>
-          </a:solidFill>
-          <a:ln/>
-        </p:spPr>
-      </p:sp>
-      <p:sp>
-        <p:nvSpPr>
-          <p:cNvPr id="7" name="Text 5"/>
-          <p:cNvSpPr txBox="1"/>
-          <p:nvPr/>
-        </p:nvSpPr>
-        <p:spPr>
-          <a:xfrm>
-            <a:off x="1554480" y="2834640"/>
-            <a:ext cx="6035040" cy="274320"/>
-          </a:xfrm>
-          <a:prstGeom prst="rect">
-            <a:avLst/>
-          </a:prstGeom>
-          <a:noFill/>
-          <a:ln/>
-        </p:spPr>
-        <p:txBody>
-          <a:bodyPr wrap="square" rtlCol="0" anchor="ctr"/>
-          <a:lstStyle/>
-          <a:p>
-            <a:pPr indent="0" marL="0">
-              <a:buNone/>
-            </a:pPr>
-            <a:r>
-              <a:rPr lang="en-US" sz="1600" dirty="0">
+            <a:pPr algn="ctr" indent="0" marL="0">
+              <a:buNone/>
+            </a:pPr>
+            <a:r>
+              <a:rPr lang="en-US" sz="1300" b="1" dirty="0">
                 <a:solidFill>
                   <a:srgbClr val="FFFFFF"/>
                 </a:solidFill>
               </a:rPr>
-              <a:t>Key Insight:</a:t>
-            </a:r>
-            <a:endParaRPr lang="en-US" sz="1600" dirty="0"/>
-          </a:p>
-        </p:txBody>
-      </p:sp>
-      <p:sp>
-        <p:nvSpPr>
-          <p:cNvPr id="8" name="Text 6"/>
-          <p:cNvSpPr txBox="1"/>
-          <p:nvPr/>
-        </p:nvSpPr>
-        <p:spPr>
-          <a:xfrm>
-            <a:off x="1554480" y="3154680"/>
-            <a:ext cx="6035040" cy="274320"/>
-          </a:xfrm>
-          <a:prstGeom prst="rect">
-            <a:avLst/>
-          </a:prstGeom>
-          <a:noFill/>
-          <a:ln/>
-        </p:spPr>
-        <p:txBody>
-          <a:bodyPr wrap="square" rtlCol="0" anchor="ctr"/>
-          <a:lstStyle/>
-          <a:p>
-            <a:pPr indent="0" marL="0">
-              <a:buNone/>
-            </a:pPr>
-            <a:r>
-              <a:rPr lang="en-US" sz="1800" b="1" dirty="0">
+              <a:t>The 2 misses from Stage 2 would be</a:t>
+            </a:r>
+            <a:endParaRPr lang="en-US" sz="1300" dirty="0"/>
+          </a:p>
+          <a:p>
+            <a:pPr algn="ctr" indent="0" marL="0">
+              <a:buNone/>
+            </a:pPr>
+            <a:r>
+              <a:rPr lang="en-US" sz="1300" b="1" dirty="0">
                 <a:solidFill>
                   <a:srgbClr val="FFFFFF"/>
                 </a:solidFill>
               </a:rPr>
-              <a:t>Perfect recall on safety-critical real objects</a:t>
-            </a:r>
-            <a:endParaRPr lang="en-US" sz="1800" dirty="0"/>
-          </a:p>
-        </p:txBody>
-      </p:sp>
-      <p:sp>
-        <p:nvSpPr>
-          <p:cNvPr id="9" name="Text 7"/>
-          <p:cNvSpPr txBox="1"/>
-          <p:nvPr/>
-        </p:nvSpPr>
-        <p:spPr>
-          <a:xfrm>
-            <a:off x="731520" y="4114800"/>
-            <a:ext cx="7680960" cy="274320"/>
-          </a:xfrm>
-          <a:prstGeom prst="rect">
-            <a:avLst/>
-          </a:prstGeom>
-          <a:noFill/>
-          <a:ln/>
-        </p:spPr>
-        <p:txBody>
-          <a:bodyPr wrap="square" rtlCol="0" anchor="ctr"/>
-          <a:lstStyle/>
-          <a:p>
-            <a:pPr indent="0" marL="0">
-              <a:buNone/>
-            </a:pPr>
-            <a:r>
-              <a:rPr lang="en-US" sz="1200" i="1" dirty="0">
-                <a:solidFill>
-                  <a:srgbClr val="2C2C2C"/>
-                </a:solidFill>
-              </a:rPr>
-              <a:t>Reference: See Figure 3 (TPR/FPR Comparison graph)</a:t>
-            </a:r>
-            <a:endParaRPr lang="en-US" sz="1200" dirty="0"/>
+              <a:t>unrecoverable if Stage 1 missed them!</a:t>
+            </a:r>
+            <a:endParaRPr lang="en-US" sz="1300" dirty="0"/>
           </a:p>
         </p:txBody>
       </p:sp>
@@ -7009,22 +5123,46 @@
                   <a:srgbClr val="1E2761"/>
                 </a:solidFill>
               </a:rPr>
-              <a:t>Stage 2: Real vs Decoy Classification</a:t>
+              <a:t>Stage 1: Confidence Distribution Analysis</a:t>
             </a:r>
             <a:endParaRPr lang="en-US" sz="3600" dirty="0"/>
           </a:p>
         </p:txBody>
       </p:sp>
-      <p:sp>
-        <p:nvSpPr>
-          <p:cNvPr id="3" name="Text 1"/>
+      <p:pic>
+        <p:nvPicPr>
+          <p:cNvPr id="3" name="Image 0" descr="/Users/kelechiezekwe/Workspace/Computer_vision_lab/Project_work/outputs/visualizations/4_confidence_distribution.png">    </p:cNvPr>
+          <p:cNvPicPr>
+            <a:picLocks noChangeAspect="1"/>
+          </p:cNvPicPr>
+          <p:nvPr/>
+        </p:nvPicPr>
+        <p:blipFill>
+          <a:blip r:embed="rId1"/>
+          <a:stretch>
+            <a:fillRect/>
+          </a:stretch>
+        </p:blipFill>
+        <p:spPr>
+          <a:xfrm>
+            <a:off x="731520" y="1097280"/>
+            <a:ext cx="7680960" cy="3474720"/>
+          </a:xfrm>
+          <a:prstGeom prst="rect">
+            <a:avLst/>
+          </a:prstGeom>
+        </p:spPr>
+      </p:pic>
+      <p:sp>
+        <p:nvSpPr>
+          <p:cNvPr id="4" name="Text 1"/>
           <p:cNvSpPr txBox="1"/>
           <p:nvPr/>
         </p:nvSpPr>
         <p:spPr>
           <a:xfrm>
-            <a:off x="457200" y="868680"/>
-            <a:ext cx="8229600" cy="274320"/>
+            <a:off x="731520" y="4663440"/>
+            <a:ext cx="7680960" cy="274320"/>
           </a:xfrm>
           <a:prstGeom prst="rect">
             <a:avLst/>
@@ -7036,306 +5174,18 @@
           <a:bodyPr wrap="square" rtlCol="0" anchor="ctr"/>
           <a:lstStyle/>
           <a:p>
-            <a:pPr indent="0" marL="0">
+            <a:pPr algn="ctr" indent="0" marL="0">
               <a:buNone/>
             </a:pPr>
             <a:r>
               <a:rPr lang="en-US" sz="1400" i="1" dirty="0">
                 <a:solidFill>
-                  <a:srgbClr val="028090"/>
-                </a:solidFill>
-              </a:rPr>
-              <a:t>Responsible: Shravani Kuchi</a:t>
+                  <a:srgbClr val="2C2C2C"/>
+                </a:solidFill>
+              </a:rPr>
+              <a:t>Threshold: 0.10 (intentionally low for maximum sensitivity)</a:t>
             </a:r>
             <a:endParaRPr lang="en-US" sz="1400" dirty="0"/>
-          </a:p>
-        </p:txBody>
-      </p:sp>
-      <p:sp>
-        <p:nvSpPr>
-          <p:cNvPr id="4" name="Text 2"/>
-          <p:cNvSpPr txBox="1"/>
-          <p:nvPr/>
-        </p:nvSpPr>
-        <p:spPr>
-          <a:xfrm>
-            <a:off x="731520" y="1280160"/>
-            <a:ext cx="7680960" cy="274320"/>
-          </a:xfrm>
-          <a:prstGeom prst="rect">
-            <a:avLst/>
-          </a:prstGeom>
-          <a:noFill/>
-          <a:ln/>
-        </p:spPr>
-        <p:txBody>
-          <a:bodyPr wrap="square" rtlCol="0" anchor="ctr"/>
-          <a:lstStyle/>
-          <a:p>
-            <a:pPr indent="0" marL="0">
-              <a:buNone/>
-            </a:pPr>
-            <a:r>
-              <a:rPr lang="en-US" sz="1800" b="1" dirty="0">
-                <a:solidFill>
-                  <a:srgbClr val="1E2761"/>
-                </a:solidFill>
-              </a:rPr>
-              <a:t>Method: Depth-based geometric cues</a:t>
-            </a:r>
-            <a:endParaRPr lang="en-US" sz="1800" dirty="0"/>
-          </a:p>
-        </p:txBody>
-      </p:sp>
-      <p:sp>
-        <p:nvSpPr>
-          <p:cNvPr id="5" name="Shape 3"/>
-          <p:cNvSpPr/>
-          <p:nvPr/>
-        </p:nvSpPr>
-        <p:spPr>
-          <a:xfrm>
-            <a:off x="731520" y="1737360"/>
-            <a:ext cx="7680960" cy="1005840"/>
-          </a:xfrm>
-          <a:prstGeom prst="rect">
-            <a:avLst/>
-          </a:prstGeom>
-          <a:solidFill>
-            <a:srgbClr val="F5F5F5"/>
-          </a:solidFill>
-          <a:ln/>
-        </p:spPr>
-      </p:sp>
-      <p:sp>
-        <p:nvSpPr>
-          <p:cNvPr id="6" name="Text 4"/>
-          <p:cNvSpPr txBox="1"/>
-          <p:nvPr/>
-        </p:nvSpPr>
-        <p:spPr>
-          <a:xfrm>
-            <a:off x="914400" y="1828800"/>
-            <a:ext cx="7315200" cy="274320"/>
-          </a:xfrm>
-          <a:prstGeom prst="rect">
-            <a:avLst/>
-          </a:prstGeom>
-          <a:noFill/>
-          <a:ln/>
-        </p:spPr>
-        <p:txBody>
-          <a:bodyPr wrap="square" rtlCol="0" anchor="ctr"/>
-          <a:lstStyle/>
-          <a:p>
-            <a:pPr indent="0" marL="0">
-              <a:buNone/>
-            </a:pPr>
-            <a:r>
-              <a:rPr lang="en-US" sz="1600" b="1" dirty="0">
-                <a:solidFill>
-                  <a:srgbClr val="028090"/>
-                </a:solidFill>
-              </a:rPr>
-              <a:t>Feature 1: Height in metres</a:t>
-            </a:r>
-            <a:endParaRPr lang="en-US" sz="1600" dirty="0"/>
-          </a:p>
-        </p:txBody>
-      </p:sp>
-      <p:sp>
-        <p:nvSpPr>
-          <p:cNvPr id="7" name="Text 5"/>
-          <p:cNvSpPr txBox="1"/>
-          <p:nvPr/>
-        </p:nvSpPr>
-        <p:spPr>
-          <a:xfrm>
-            <a:off x="914400" y="2148840"/>
-            <a:ext cx="7315200" cy="548640"/>
-          </a:xfrm>
-          <a:prstGeom prst="rect">
-            <a:avLst/>
-          </a:prstGeom>
-          <a:noFill/>
-          <a:ln/>
-        </p:spPr>
-        <p:txBody>
-          <a:bodyPr wrap="square" rtlCol="0" anchor="ctr"/>
-          <a:lstStyle/>
-          <a:p>
-            <a:pPr marL="342900" indent="-342900">
-              <a:buSzPct val="100000"/>
-              <a:buChar char="•"/>
-            </a:pPr>
-            <a:r>
-              <a:rPr lang="en-US" sz="1400" dirty="0">
-                <a:solidFill>
-                  <a:srgbClr val="2C2C2C"/>
-                </a:solidFill>
-              </a:rPr>
-              <a:t>• height_m = box_height × depth / fy</a:t>
-            </a:r>
-            <a:endParaRPr lang="en-US" sz="1400" dirty="0"/>
-          </a:p>
-          <a:p>
-            <a:pPr marL="342900" indent="-342900">
-              <a:buSzPct val="100000"/>
-              <a:buChar char="•"/>
-            </a:pPr>
-            <a:r>
-              <a:rPr lang="en-US" sz="1400" dirty="0">
-                <a:solidFill>
-                  <a:srgbClr val="2C2C2C"/>
-                </a:solidFill>
-              </a:rPr>
-              <a:t>• Real: ~0.58m, Decoy: ~0.31m</a:t>
-            </a:r>
-            <a:endParaRPr lang="en-US" sz="1400" dirty="0"/>
-          </a:p>
-        </p:txBody>
-      </p:sp>
-      <p:sp>
-        <p:nvSpPr>
-          <p:cNvPr id="8" name="Shape 6"/>
-          <p:cNvSpPr/>
-          <p:nvPr/>
-        </p:nvSpPr>
-        <p:spPr>
-          <a:xfrm>
-            <a:off x="731520" y="2926080"/>
-            <a:ext cx="7680960" cy="1005840"/>
-          </a:xfrm>
-          <a:prstGeom prst="rect">
-            <a:avLst/>
-          </a:prstGeom>
-          <a:solidFill>
-            <a:srgbClr val="F5F5F5"/>
-          </a:solidFill>
-          <a:ln/>
-        </p:spPr>
-      </p:sp>
-      <p:sp>
-        <p:nvSpPr>
-          <p:cNvPr id="9" name="Text 7"/>
-          <p:cNvSpPr txBox="1"/>
-          <p:nvPr/>
-        </p:nvSpPr>
-        <p:spPr>
-          <a:xfrm>
-            <a:off x="914400" y="3017520"/>
-            <a:ext cx="7315200" cy="274320"/>
-          </a:xfrm>
-          <a:prstGeom prst="rect">
-            <a:avLst/>
-          </a:prstGeom>
-          <a:noFill/>
-          <a:ln/>
-        </p:spPr>
-        <p:txBody>
-          <a:bodyPr wrap="square" rtlCol="0" anchor="ctr"/>
-          <a:lstStyle/>
-          <a:p>
-            <a:pPr indent="0" marL="0">
-              <a:buNone/>
-            </a:pPr>
-            <a:r>
-              <a:rPr lang="en-US" sz="1600" b="1" dirty="0">
-                <a:solidFill>
-                  <a:srgbClr val="028090"/>
-                </a:solidFill>
-              </a:rPr>
-              <a:t>Feature 2: Depth contrast</a:t>
-            </a:r>
-            <a:endParaRPr lang="en-US" sz="1600" dirty="0"/>
-          </a:p>
-        </p:txBody>
-      </p:sp>
-      <p:sp>
-        <p:nvSpPr>
-          <p:cNvPr id="10" name="Text 8"/>
-          <p:cNvSpPr txBox="1"/>
-          <p:nvPr/>
-        </p:nvSpPr>
-        <p:spPr>
-          <a:xfrm>
-            <a:off x="914400" y="3337560"/>
-            <a:ext cx="7315200" cy="548640"/>
-          </a:xfrm>
-          <a:prstGeom prst="rect">
-            <a:avLst/>
-          </a:prstGeom>
-          <a:noFill/>
-          <a:ln/>
-        </p:spPr>
-        <p:txBody>
-          <a:bodyPr wrap="square" rtlCol="0" anchor="ctr"/>
-          <a:lstStyle/>
-          <a:p>
-            <a:pPr marL="342900" indent="-342900">
-              <a:buSzPct val="100000"/>
-              <a:buChar char="•"/>
-            </a:pPr>
-            <a:r>
-              <a:rPr lang="en-US" sz="1400" dirty="0">
-                <a:solidFill>
-                  <a:srgbClr val="2C2C2C"/>
-                </a:solidFill>
-              </a:rPr>
-              <a:t>• contrast = (ring_depth - object_depth) / depth</a:t>
-            </a:r>
-            <a:endParaRPr lang="en-US" sz="1400" dirty="0"/>
-          </a:p>
-          <a:p>
-            <a:pPr marL="342900" indent="-342900">
-              <a:buSzPct val="100000"/>
-              <a:buChar char="•"/>
-            </a:pPr>
-            <a:r>
-              <a:rPr lang="en-US" sz="1400" dirty="0">
-                <a:solidFill>
-                  <a:srgbClr val="2C2C2C"/>
-                </a:solidFill>
-              </a:rPr>
-              <a:t>• Real: ~0.45 (free space), Decoy: ~0.02 (flat)</a:t>
-            </a:r>
-            <a:endParaRPr lang="en-US" sz="1400" dirty="0"/>
-          </a:p>
-        </p:txBody>
-      </p:sp>
-      <p:sp>
-        <p:nvSpPr>
-          <p:cNvPr id="11" name="Text 9"/>
-          <p:cNvSpPr txBox="1"/>
-          <p:nvPr/>
-        </p:nvSpPr>
-        <p:spPr>
-          <a:xfrm>
-            <a:off x="731520" y="4206240"/>
-            <a:ext cx="7680960" cy="365760"/>
-          </a:xfrm>
-          <a:prstGeom prst="rect">
-            <a:avLst/>
-          </a:prstGeom>
-          <a:noFill/>
-          <a:ln/>
-        </p:spPr>
-        <p:txBody>
-          <a:bodyPr wrap="square" rtlCol="0" anchor="ctr"/>
-          <a:lstStyle/>
-          <a:p>
-            <a:pPr algn="ctr" indent="0" marL="0">
-              <a:buNone/>
-            </a:pPr>
-            <a:r>
-              <a:rPr lang="en-US" sz="1500" b="1" dirty="0">
-                <a:solidFill>
-                  <a:srgbClr val="F96167"/>
-                </a:solidFill>
-              </a:rPr>
-              <a:t>Decision Rule: REAL if height ≥ 0.5554m AND contrast ≥ 0.1922</a:t>
-            </a:r>
-            <a:endParaRPr lang="en-US" sz="1500" dirty="0"/>
           </a:p>
         </p:txBody>
       </p:sp>
@@ -7401,7 +5251,7 @@
                   <a:srgbClr val="1E2761"/>
                 </a:solidFill>
               </a:rPr>
-              <a:t>Stage 2: Zero False Positives Achieved</a:t>
+              <a:t>Stage 2: Real Objects Accepted</a:t>
             </a:r>
             <a:endParaRPr lang="en-US" sz="3600" dirty="0"/>
           </a:p>
@@ -7415,7 +5265,67 @@
         </p:nvSpPr>
         <p:spPr>
           <a:xfrm>
-            <a:off x="731520" y="1097280"/>
+            <a:off x="457200" y="868680"/>
+            <a:ext cx="8229600" cy="274320"/>
+          </a:xfrm>
+          <a:prstGeom prst="rect">
+            <a:avLst/>
+          </a:prstGeom>
+          <a:noFill/>
+          <a:ln/>
+        </p:spPr>
+        <p:txBody>
+          <a:bodyPr wrap="square" rtlCol="0" anchor="ctr"/>
+          <a:lstStyle/>
+          <a:p>
+            <a:pPr indent="0" marL="0">
+              <a:buNone/>
+            </a:pPr>
+            <a:r>
+              <a:rPr lang="en-US" sz="1400" i="1" dirty="0">
+                <a:solidFill>
+                  <a:srgbClr val="028090"/>
+                </a:solidFill>
+              </a:rPr>
+              <a:t>Responsible: Shravani Kuchi | Depth-based Filtering</a:t>
+            </a:r>
+            <a:endParaRPr lang="en-US" sz="1400" dirty="0"/>
+          </a:p>
+        </p:txBody>
+      </p:sp>
+      <p:pic>
+        <p:nvPicPr>
+          <p:cNvPr id="4" name="Image 0" descr="/Users/kelechiezekwe/Workspace/Computer_vision_lab/Project_work/outputs/figures/ev_real_accepted.png">    </p:cNvPr>
+          <p:cNvPicPr>
+            <a:picLocks noChangeAspect="1"/>
+          </p:cNvPicPr>
+          <p:nvPr/>
+        </p:nvPicPr>
+        <p:blipFill>
+          <a:blip r:embed="rId1"/>
+          <a:stretch>
+            <a:fillRect/>
+          </a:stretch>
+        </p:blipFill>
+        <p:spPr>
+          <a:xfrm>
+            <a:off x="914400" y="1371600"/>
+            <a:ext cx="7315200" cy="3200400"/>
+          </a:xfrm>
+          <a:prstGeom prst="rect">
+            <a:avLst/>
+          </a:prstGeom>
+        </p:spPr>
+      </p:pic>
+      <p:sp>
+        <p:nvSpPr>
+          <p:cNvPr id="5" name="Text 2"/>
+          <p:cNvSpPr txBox="1"/>
+          <p:nvPr/>
+        </p:nvSpPr>
+        <p:spPr>
+          <a:xfrm>
+            <a:off x="731520" y="4663440"/>
             <a:ext cx="7680960" cy="274320"/>
           </a:xfrm>
           <a:prstGeom prst="rect">
@@ -7428,259 +5338,18 @@
           <a:bodyPr wrap="square" rtlCol="0" anchor="ctr"/>
           <a:lstStyle/>
           <a:p>
-            <a:pPr indent="0" marL="0">
-              <a:buNone/>
-            </a:pPr>
-            <a:r>
-              <a:rPr lang="en-US" sz="2000" b="1" dirty="0">
-                <a:solidFill>
-                  <a:srgbClr val="028090"/>
-                </a:solidFill>
-              </a:rPr>
-              <a:t>Test Set Results:</a:t>
-            </a:r>
-            <a:endParaRPr lang="en-US" sz="2000" dirty="0"/>
-          </a:p>
-        </p:txBody>
-      </p:sp>
-      <p:sp>
-        <p:nvSpPr>
-          <p:cNvPr id="4" name="Text 2"/>
-          <p:cNvSpPr txBox="1"/>
-          <p:nvPr/>
-        </p:nvSpPr>
-        <p:spPr>
-          <a:xfrm>
-            <a:off x="731520" y="1463040"/>
-            <a:ext cx="3657600" cy="822960"/>
-          </a:xfrm>
-          <a:prstGeom prst="rect">
-            <a:avLst/>
-          </a:prstGeom>
-          <a:noFill/>
-          <a:ln/>
-        </p:spPr>
-        <p:txBody>
-          <a:bodyPr wrap="square" rtlCol="0" anchor="ctr"/>
-          <a:lstStyle/>
-          <a:p>
-            <a:pPr marL="342900" indent="-342900">
-              <a:buSzPct val="100000"/>
-              <a:buChar char="•"/>
-            </a:pPr>
-            <a:r>
-              <a:rPr lang="en-US" sz="1500" b="1" dirty="0">
+            <a:pPr algn="ctr" indent="0" marL="0">
+              <a:buNone/>
+            </a:pPr>
+            <a:r>
+              <a:rPr lang="en-US" sz="1600" b="1" dirty="0">
                 <a:solidFill>
                   <a:srgbClr val="2C5F2D"/>
                 </a:solidFill>
               </a:rPr>
-              <a:t>• Decoys accepted: 0/103 (0%)</a:t>
-            </a:r>
-            <a:endParaRPr lang="en-US" sz="1500" dirty="0"/>
-          </a:p>
-          <a:p>
-            <a:pPr marL="342900" indent="-342900">
-              <a:buSzPct val="100000"/>
-              <a:buChar char="•"/>
-            </a:pPr>
-            <a:r>
-              <a:rPr lang="en-US" sz="1500" b="1" dirty="0">
-                <a:solidFill>
-                  <a:srgbClr val="2C5F2D"/>
-                </a:solidFill>
-              </a:rPr>
-              <a:t>• Decoys rejected: 103/103 (100%)</a:t>
-            </a:r>
-            <a:endParaRPr lang="en-US" sz="1500" dirty="0"/>
-          </a:p>
-          <a:p>
-            <a:pPr marL="342900" indent="-342900">
-              <a:buSzPct val="100000"/>
-              <a:buChar char="•"/>
-            </a:pPr>
-            <a:r>
-              <a:rPr lang="en-US" sz="1500" b="1" dirty="0">
-                <a:solidFill>
-                  <a:srgbClr val="2C5F2D"/>
-                </a:solidFill>
-              </a:rPr>
-              <a:t>• FPR: 0.0000 ✓ (target ≤ 0.15)</a:t>
-            </a:r>
-            <a:endParaRPr lang="en-US" sz="1500" dirty="0"/>
-          </a:p>
-        </p:txBody>
-      </p:sp>
-      <p:sp>
-        <p:nvSpPr>
-          <p:cNvPr id="5" name="Text 3"/>
-          <p:cNvSpPr txBox="1"/>
-          <p:nvPr/>
-        </p:nvSpPr>
-        <p:spPr>
-          <a:xfrm>
-            <a:off x="4754880" y="1463040"/>
-            <a:ext cx="3657600" cy="1097280"/>
-          </a:xfrm>
-          <a:prstGeom prst="rect">
-            <a:avLst/>
-          </a:prstGeom>
-          <a:noFill/>
-          <a:ln/>
-        </p:spPr>
-        <p:txBody>
-          <a:bodyPr wrap="square" rtlCol="0" anchor="ctr"/>
-          <a:lstStyle/>
-          <a:p>
-            <a:pPr marL="342900" indent="-342900">
-              <a:buSzPct val="100000"/>
-              <a:buChar char="•"/>
-            </a:pPr>
-            <a:r>
-              <a:rPr lang="en-US" sz="1500" dirty="0">
-                <a:solidFill>
-                  <a:srgbClr val="2C2C2C"/>
-                </a:solidFill>
-              </a:rPr>
-              <a:t>• Real accepted: 43/45</a:t>
-            </a:r>
-            <a:endParaRPr lang="en-US" sz="1500" dirty="0"/>
-          </a:p>
-          <a:p>
-            <a:pPr marL="342900" indent="-342900">
-              <a:buSzPct val="100000"/>
-              <a:buChar char="•"/>
-            </a:pPr>
-            <a:r>
-              <a:rPr lang="en-US" sz="1500" dirty="0">
-                <a:solidFill>
-                  <a:srgbClr val="2C2C2C"/>
-                </a:solidFill>
-              </a:rPr>
-              <a:t>• Real rejected: 2/45</a:t>
-            </a:r>
-            <a:endParaRPr lang="en-US" sz="1500" dirty="0"/>
-          </a:p>
-          <a:p>
-            <a:pPr marL="342900" indent="-342900">
-              <a:buSzPct val="100000"/>
-              <a:buChar char="•"/>
-            </a:pPr>
-            <a:r>
-              <a:rPr lang="en-US" sz="1500" dirty="0">
-                <a:solidFill>
-                  <a:srgbClr val="2C2C2C"/>
-                </a:solidFill>
-              </a:rPr>
-              <a:t>  (timing edge cases)</a:t>
-            </a:r>
-            <a:endParaRPr lang="en-US" sz="1500" dirty="0"/>
-          </a:p>
-          <a:p>
-            <a:pPr marL="342900" indent="-342900">
-              <a:buSzPct val="100000"/>
-              <a:buChar char="•"/>
-            </a:pPr>
-            <a:r>
-              <a:rPr lang="en-US" sz="1500" dirty="0">
-                <a:solidFill>
-                  <a:srgbClr val="2C2C2C"/>
-                </a:solidFill>
-              </a:rPr>
-              <a:t>• TPR: 0.9556 ✓ (target ≥ 0.75)</a:t>
-            </a:r>
-            <a:endParaRPr lang="en-US" sz="1500" dirty="0"/>
-          </a:p>
-        </p:txBody>
-      </p:sp>
-      <p:sp>
-        <p:nvSpPr>
-          <p:cNvPr id="6" name="Shape 4"/>
-          <p:cNvSpPr/>
-          <p:nvPr/>
-        </p:nvSpPr>
-        <p:spPr>
-          <a:xfrm>
-            <a:off x="1371600" y="2926080"/>
-            <a:ext cx="6400800" cy="640080"/>
-          </a:xfrm>
-          <a:prstGeom prst="rect">
-            <a:avLst/>
-          </a:prstGeom>
-          <a:solidFill>
-            <a:srgbClr val="00A896"/>
-          </a:solidFill>
-          <a:ln/>
-        </p:spPr>
-      </p:sp>
-      <p:sp>
-        <p:nvSpPr>
-          <p:cNvPr id="7" name="Text 5"/>
-          <p:cNvSpPr txBox="1"/>
-          <p:nvPr/>
-        </p:nvSpPr>
-        <p:spPr>
-          <a:xfrm>
-            <a:off x="1554480" y="3063240"/>
-            <a:ext cx="6035040" cy="365760"/>
-          </a:xfrm>
-          <a:prstGeom prst="rect">
-            <a:avLst/>
-          </a:prstGeom>
-          <a:noFill/>
-          <a:ln/>
-        </p:spPr>
-        <p:txBody>
-          <a:bodyPr wrap="square" rtlCol="0" anchor="ctr"/>
-          <a:lstStyle/>
-          <a:p>
-            <a:pPr algn="ctr" indent="0" marL="0">
-              <a:buNone/>
-            </a:pPr>
-            <a:r>
-              <a:rPr lang="en-US" sz="2200" b="1" dirty="0">
-                <a:solidFill>
-                  <a:srgbClr val="FFFFFF"/>
-                </a:solidFill>
-              </a:rPr>
-              <a:t>FPR Improvement: 60% → 0% (perfect!)</a:t>
-            </a:r>
-            <a:endParaRPr lang="en-US" sz="2200" dirty="0"/>
-          </a:p>
-        </p:txBody>
-      </p:sp>
-      <p:sp>
-        <p:nvSpPr>
-          <p:cNvPr id="8" name="Text 6"/>
-          <p:cNvSpPr txBox="1"/>
-          <p:nvPr/>
-        </p:nvSpPr>
-        <p:spPr>
-          <a:xfrm>
-            <a:off x="731520" y="4114800"/>
-            <a:ext cx="7680960" cy="274320"/>
-          </a:xfrm>
-          <a:prstGeom prst="rect">
-            <a:avLst/>
-          </a:prstGeom>
-          <a:noFill/>
-          <a:ln/>
-        </p:spPr>
-        <p:txBody>
-          <a:bodyPr wrap="square" rtlCol="0" anchor="ctr"/>
-          <a:lstStyle/>
-          <a:p>
-            <a:pPr indent="0" marL="0">
-              <a:buNone/>
-            </a:pPr>
-            <a:r>
-              <a:rPr lang="en-US" sz="1200" i="1" dirty="0">
-                <a:solidFill>
-                  <a:srgbClr val="2C2C2C"/>
-                </a:solidFill>
-              </a:rPr>
-              <a:t>Reference: See Figure 8 (Decoys Rejected graph)</a:t>
-            </a:r>
-            <a:endParaRPr lang="en-US" sz="1200" dirty="0"/>
+              <a:t>43/45 real objects accepted (96% TPR)</a:t>
+            </a:r>
+            <a:endParaRPr lang="en-US" sz="1600" dirty="0"/>
           </a:p>
         </p:txBody>
       </p:sp>
@@ -7741,27 +5410,71 @@
               <a:buNone/>
             </a:pPr>
             <a:r>
-              <a:rPr lang="en-US" sz="3200" b="1" dirty="0">
+              <a:rPr lang="en-US" sz="3600" b="1" dirty="0">
                 <a:solidFill>
                   <a:srgbClr val="1E2761"/>
                 </a:solidFill>
               </a:rPr>
-              <a:t>Edge Case Analysis: Why 2 Real Objects Were Rejected</a:t>
-            </a:r>
-            <a:endParaRPr lang="en-US" sz="3200" dirty="0"/>
-          </a:p>
-        </p:txBody>
-      </p:sp>
-      <p:sp>
-        <p:nvSpPr>
-          <p:cNvPr id="3" name="Text 1"/>
+              <a:t>Stage 2: Perfect Decoy Rejection</a:t>
+            </a:r>
+            <a:endParaRPr lang="en-US" sz="3600" dirty="0"/>
+          </a:p>
+        </p:txBody>
+      </p:sp>
+      <p:pic>
+        <p:nvPicPr>
+          <p:cNvPr id="3" name="Image 0" descr="/Users/kelechiezekwe/Workspace/Computer_vision_lab/Project_work/outputs/figures/ev_decoys_rejected.png">    </p:cNvPr>
+          <p:cNvPicPr>
+            <a:picLocks noChangeAspect="1"/>
+          </p:cNvPicPr>
+          <p:nvPr/>
+        </p:nvPicPr>
+        <p:blipFill>
+          <a:blip r:embed="rId1"/>
+          <a:stretch>
+            <a:fillRect/>
+          </a:stretch>
+        </p:blipFill>
+        <p:spPr>
+          <a:xfrm>
+            <a:off x="914400" y="1097280"/>
+            <a:ext cx="7315200" cy="3200400"/>
+          </a:xfrm>
+          <a:prstGeom prst="rect">
+            <a:avLst/>
+          </a:prstGeom>
+        </p:spPr>
+      </p:pic>
+      <p:sp>
+        <p:nvSpPr>
+          <p:cNvPr id="4" name="Shape 1"/>
+          <p:cNvSpPr/>
+          <p:nvPr/>
+        </p:nvSpPr>
+        <p:spPr>
+          <a:xfrm>
+            <a:off x="1828800" y="4480560"/>
+            <a:ext cx="5486400" cy="548640"/>
+          </a:xfrm>
+          <a:prstGeom prst="rect">
+            <a:avLst/>
+          </a:prstGeom>
+          <a:solidFill>
+            <a:srgbClr val="00A896"/>
+          </a:solidFill>
+          <a:ln/>
+        </p:spPr>
+      </p:sp>
+      <p:sp>
+        <p:nvSpPr>
+          <p:cNvPr id="5" name="Text 2"/>
           <p:cNvSpPr txBox="1"/>
           <p:nvPr/>
         </p:nvSpPr>
         <p:spPr>
           <a:xfrm>
-            <a:off x="731520" y="1097280"/>
-            <a:ext cx="7680960" cy="274320"/>
+            <a:off x="2011680" y="4572000"/>
+            <a:ext cx="5120640" cy="365760"/>
           </a:xfrm>
           <a:prstGeom prst="rect">
             <a:avLst/>
@@ -7773,192 +5486,18 @@
           <a:bodyPr wrap="square" rtlCol="0" anchor="ctr"/>
           <a:lstStyle/>
           <a:p>
-            <a:pPr indent="0" marL="0">
+            <a:pPr algn="ctr" indent="0" marL="0">
               <a:buNone/>
             </a:pPr>
             <a:r>
               <a:rPr lang="en-US" sz="2000" b="1" dirty="0">
                 <a:solidFill>
-                  <a:srgbClr val="F96167"/>
-                </a:solidFill>
-              </a:rPr>
-              <a:t>Root Cause: Colour/Depth Timing Mismatch</a:t>
+                  <a:srgbClr val="FFFFFF"/>
+                </a:solidFill>
+              </a:rPr>
+              <a:t>0% FPR - All 103 decoys rejected!</a:t>
             </a:r>
             <a:endParaRPr lang="en-US" sz="2000" dirty="0"/>
-          </a:p>
-        </p:txBody>
-      </p:sp>
-      <p:sp>
-        <p:nvSpPr>
-          <p:cNvPr id="4" name="Text 2"/>
-          <p:cNvSpPr txBox="1"/>
-          <p:nvPr/>
-        </p:nvSpPr>
-        <p:spPr>
-          <a:xfrm>
-            <a:off x="731520" y="1463040"/>
-            <a:ext cx="7680960" cy="1097280"/>
-          </a:xfrm>
-          <a:prstGeom prst="rect">
-            <a:avLst/>
-          </a:prstGeom>
-          <a:noFill/>
-          <a:ln/>
-        </p:spPr>
-        <p:txBody>
-          <a:bodyPr wrap="square" rtlCol="0" anchor="ctr"/>
-          <a:lstStyle/>
-          <a:p>
-            <a:pPr marL="342900" indent="-342900">
-              <a:buSzPct val="100000"/>
-              <a:buChar char="•"/>
-            </a:pPr>
-            <a:r>
-              <a:rPr lang="en-US" sz="1600" dirty="0">
-                <a:solidFill>
-                  <a:srgbClr val="2C2C2C"/>
-                </a:solidFill>
-              </a:rPr>
-              <a:t>• Camera turning rapidly</a:t>
-            </a:r>
-            <a:endParaRPr lang="en-US" sz="1600" dirty="0"/>
-          </a:p>
-          <a:p>
-            <a:pPr marL="342900" indent="-342900">
-              <a:buSzPct val="100000"/>
-              <a:buChar char="•"/>
-            </a:pPr>
-            <a:r>
-              <a:rPr lang="en-US" sz="1600" dirty="0">
-                <a:solidFill>
-                  <a:srgbClr val="2C2C2C"/>
-                </a:solidFill>
-              </a:rPr>
-              <a:t>• Depth frame 28ms and 45ms older than colour</a:t>
-            </a:r>
-            <a:endParaRPr lang="en-US" sz="1600" dirty="0"/>
-          </a:p>
-          <a:p>
-            <a:pPr marL="342900" indent="-342900">
-              <a:buSzPct val="100000"/>
-              <a:buChar char="•"/>
-            </a:pPr>
-            <a:r>
-              <a:rPr lang="en-US" sz="1600" dirty="0">
-                <a:solidFill>
-                  <a:srgbClr val="2C2C2C"/>
-                </a:solidFill>
-              </a:rPr>
-              <a:t>• Object moved between frames</a:t>
-            </a:r>
-            <a:endParaRPr lang="en-US" sz="1600" dirty="0"/>
-          </a:p>
-          <a:p>
-            <a:pPr marL="342900" indent="-342900">
-              <a:buSzPct val="100000"/>
-              <a:buChar char="•"/>
-            </a:pPr>
-            <a:r>
-              <a:rPr lang="en-US" sz="1600" dirty="0">
-                <a:solidFill>
-                  <a:srgbClr val="2C2C2C"/>
-                </a:solidFill>
-              </a:rPr>
-              <a:t>• Detection box sees floor in depth → no contrast</a:t>
-            </a:r>
-            <a:endParaRPr lang="en-US" sz="1600" dirty="0"/>
-          </a:p>
-        </p:txBody>
-      </p:sp>
-      <p:sp>
-        <p:nvSpPr>
-          <p:cNvPr id="5" name="Shape 3"/>
-          <p:cNvSpPr/>
-          <p:nvPr/>
-        </p:nvSpPr>
-        <p:spPr>
-          <a:xfrm>
-            <a:off x="914400" y="2834640"/>
-            <a:ext cx="7315200" cy="548640"/>
-          </a:xfrm>
-          <a:prstGeom prst="rect">
-            <a:avLst/>
-          </a:prstGeom>
-          <a:solidFill>
-            <a:srgbClr val="F5F5F5"/>
-          </a:solidFill>
-          <a:ln/>
-        </p:spPr>
-      </p:sp>
-      <p:sp>
-        <p:nvSpPr>
-          <p:cNvPr id="6" name="Text 4"/>
-          <p:cNvSpPr txBox="1"/>
-          <p:nvPr/>
-        </p:nvSpPr>
-        <p:spPr>
-          <a:xfrm>
-            <a:off x="1097280" y="2971800"/>
-            <a:ext cx="6949440" cy="274320"/>
-          </a:xfrm>
-          <a:prstGeom prst="rect">
-            <a:avLst/>
-          </a:prstGeom>
-          <a:noFill/>
-          <a:ln/>
-        </p:spPr>
-        <p:txBody>
-          <a:bodyPr wrap="square" rtlCol="0" anchor="ctr"/>
-          <a:lstStyle/>
-          <a:p>
-            <a:pPr algn="ctr" indent="0" marL="0">
-              <a:buNone/>
-            </a:pPr>
-            <a:r>
-              <a:rPr lang="en-US" sz="1600" b="1" dirty="0">
-                <a:solidFill>
-                  <a:srgbClr val="1E2761"/>
-                </a:solidFill>
-              </a:rPr>
-              <a:t>This is NOT a filter failure - it's a synchronization issue</a:t>
-            </a:r>
-            <a:endParaRPr lang="en-US" sz="1600" dirty="0"/>
-          </a:p>
-        </p:txBody>
-      </p:sp>
-      <p:sp>
-        <p:nvSpPr>
-          <p:cNvPr id="7" name="Text 5"/>
-          <p:cNvSpPr txBox="1"/>
-          <p:nvPr/>
-        </p:nvSpPr>
-        <p:spPr>
-          <a:xfrm>
-            <a:off x="731520" y="3840480"/>
-            <a:ext cx="7680960" cy="365760"/>
-          </a:xfrm>
-          <a:prstGeom prst="rect">
-            <a:avLst/>
-          </a:prstGeom>
-          <a:noFill/>
-          <a:ln/>
-        </p:spPr>
-        <p:txBody>
-          <a:bodyPr wrap="square" rtlCol="0" anchor="ctr"/>
-          <a:lstStyle/>
-          <a:p>
-            <a:pPr algn="ctr" indent="0" marL="0">
-              <a:buNone/>
-            </a:pPr>
-            <a:r>
-              <a:rPr lang="en-US" sz="1800" b="1" dirty="0">
-                <a:solidFill>
-                  <a:srgbClr val="028090"/>
-                </a:solidFill>
-              </a:rPr>
-              <a:t>Solution: Stage 3 tracking recovers both! →</a:t>
-            </a:r>
-            <a:endParaRPr lang="en-US" sz="1800" dirty="0"/>
           </a:p>
         </p:txBody>
       </p:sp>

</xml_diff>